<commit_message>
Deck: add Packet Tracer and Wireshark result slides
Co-Authored-By: Claude Sonnet 5.5 <noreply@anthropic.com>
Claude-Session: https://claude.ai/code/session_01NX2zRNpdVAnzFNKmqomzKu
</commit_message>
<xml_diff>
--- a/docs/final/RUDP_Presentation.pptx
+++ b/docs/final/RUDP_Presentation.pptx
@@ -24,9 +24,11 @@
     <p:sldId id="272" r:id="rId18"/>
     <p:sldId id="273" r:id="rId19"/>
     <p:sldId id="274" r:id="rId20"/>
+    <p:sldId id="275" r:id="rId21"/>
+    <p:sldId id="276" r:id="rId22"/>
   </p:sldIdLst>
   <p:notesMasterIdLst>
-    <p:notesMasterId r:id="rId21"/>
+    <p:notesMasterId r:id="rId23"/>
   </p:notesMasterIdLst>
   <p:sldSz cx="12192000" cy="6858000"/>
   <p:notesSz cx="6858000" cy="12192000"/>
@@ -1512,6 +1514,182 @@
             <a:fld id="{F7021451-1387-4CA6-816F-3879F97B5CBC}" type="slidenum">
               <a:rPr lang="en-US"/>
               <a:t>2</a:t>
+            </a:fld>
+            <a:endParaRPr lang="en-US"/>
+          </a:p>
+        </p:txBody>
+      </p:sp>
+    </p:spTree>
+    <p:extLst>
+      <p:ext uri="{BB962C8B-B14F-4D97-AF65-F5344CB8AC3E}">
+        <p14:creationId xmlns:p14="http://schemas.microsoft.com/office/powerpoint/2010/main" val="1024086991"/>
+      </p:ext>
+    </p:extLst>
+  </p:cSld>
+  <p:clrMapOvr>
+    <a:masterClrMapping/>
+  </p:clrMapOvr>
+</p:notes>
+</file>
+
+<file path=ppt/notesSlides/notesSlide20.xml><?xml version="1.0" encoding="utf-8"?>
+<p:notes xmlns:a="http://schemas.openxmlformats.org/drawingml/2006/main" xmlns:r="http://schemas.openxmlformats.org/officeDocument/2006/relationships" xmlns:p="http://schemas.openxmlformats.org/presentationml/2006/main">
+  <p:cSld>
+    <p:spTree>
+      <p:nvGrpSpPr>
+        <p:cNvPr id="1" name=""/>
+        <p:cNvGrpSpPr/>
+        <p:nvPr/>
+      </p:nvGrpSpPr>
+      <p:grpSpPr>
+        <a:xfrm>
+          <a:off x="0" y="0"/>
+          <a:ext cx="0" cy="0"/>
+          <a:chOff x="0" y="0"/>
+          <a:chExt cx="0" cy="0"/>
+        </a:xfrm>
+      </p:grpSpPr>
+      <p:sp>
+        <p:nvSpPr>
+          <p:cNvPr id="2" name="Slide Image Placeholder 1"/>
+          <p:cNvSpPr>
+            <a:spLocks noGrp="1" noRot="1" noChangeAspect="1"/>
+          </p:cNvSpPr>
+          <p:nvPr>
+            <p:ph type="sldImg"/>
+          </p:nvPr>
+        </p:nvSpPr>
+        <p:spPr/>
+      </p:sp>
+      <p:sp>
+        <p:nvSpPr>
+          <p:cNvPr id="3" name="Notes Placeholder 2"/>
+          <p:cNvSpPr>
+            <a:spLocks noGrp="1"/>
+          </p:cNvSpPr>
+          <p:nvPr>
+            <p:ph type="body" idx="1"/>
+          </p:nvPr>
+        </p:nvSpPr>
+        <p:spPr/>
+        <p:txBody>
+          <a:bodyPr/>
+          <a:lstStyle/>
+          <a:p>
+            <a:r>
+              <a:rPr lang="en-US" dirty="0"/>
+              <a:t/>
+            </a:r>
+            <a:endParaRPr lang="en-US" dirty="0"/>
+          </a:p>
+        </p:txBody>
+      </p:sp>
+      <p:sp>
+        <p:nvSpPr>
+          <p:cNvPr id="4" name="Slide Number Placeholder 3"/>
+          <p:cNvSpPr>
+            <a:spLocks noGrp="1"/>
+          </p:cNvSpPr>
+          <p:nvPr>
+            <p:ph type="sldNum" sz="quarter" idx="10"/>
+          </p:nvPr>
+        </p:nvSpPr>
+        <p:spPr/>
+        <p:txBody>
+          <a:bodyPr/>
+          <a:lstStyle/>
+          <a:p>
+            <a:fld id="{F7021451-1387-4CA6-816F-3879F97B5CBC}" type="slidenum">
+              <a:rPr lang="en-US"/>
+              <a:t>20</a:t>
+            </a:fld>
+            <a:endParaRPr lang="en-US"/>
+          </a:p>
+        </p:txBody>
+      </p:sp>
+    </p:spTree>
+    <p:extLst>
+      <p:ext uri="{BB962C8B-B14F-4D97-AF65-F5344CB8AC3E}">
+        <p14:creationId xmlns:p14="http://schemas.microsoft.com/office/powerpoint/2010/main" val="1024086991"/>
+      </p:ext>
+    </p:extLst>
+  </p:cSld>
+  <p:clrMapOvr>
+    <a:masterClrMapping/>
+  </p:clrMapOvr>
+</p:notes>
+</file>
+
+<file path=ppt/notesSlides/notesSlide21.xml><?xml version="1.0" encoding="utf-8"?>
+<p:notes xmlns:a="http://schemas.openxmlformats.org/drawingml/2006/main" xmlns:r="http://schemas.openxmlformats.org/officeDocument/2006/relationships" xmlns:p="http://schemas.openxmlformats.org/presentationml/2006/main">
+  <p:cSld>
+    <p:spTree>
+      <p:nvGrpSpPr>
+        <p:cNvPr id="1" name=""/>
+        <p:cNvGrpSpPr/>
+        <p:nvPr/>
+      </p:nvGrpSpPr>
+      <p:grpSpPr>
+        <a:xfrm>
+          <a:off x="0" y="0"/>
+          <a:ext cx="0" cy="0"/>
+          <a:chOff x="0" y="0"/>
+          <a:chExt cx="0" cy="0"/>
+        </a:xfrm>
+      </p:grpSpPr>
+      <p:sp>
+        <p:nvSpPr>
+          <p:cNvPr id="2" name="Slide Image Placeholder 1"/>
+          <p:cNvSpPr>
+            <a:spLocks noGrp="1" noRot="1" noChangeAspect="1"/>
+          </p:cNvSpPr>
+          <p:nvPr>
+            <p:ph type="sldImg"/>
+          </p:nvPr>
+        </p:nvSpPr>
+        <p:spPr/>
+      </p:sp>
+      <p:sp>
+        <p:nvSpPr>
+          <p:cNvPr id="3" name="Notes Placeholder 2"/>
+          <p:cNvSpPr>
+            <a:spLocks noGrp="1"/>
+          </p:cNvSpPr>
+          <p:nvPr>
+            <p:ph type="body" idx="1"/>
+          </p:nvPr>
+        </p:nvSpPr>
+        <p:spPr/>
+        <p:txBody>
+          <a:bodyPr/>
+          <a:lstStyle/>
+          <a:p>
+            <a:r>
+              <a:rPr lang="en-US" dirty="0"/>
+              <a:t/>
+            </a:r>
+            <a:endParaRPr lang="en-US" dirty="0"/>
+          </a:p>
+        </p:txBody>
+      </p:sp>
+      <p:sp>
+        <p:nvSpPr>
+          <p:cNvPr id="4" name="Slide Number Placeholder 3"/>
+          <p:cNvSpPr>
+            <a:spLocks noGrp="1"/>
+          </p:cNvSpPr>
+          <p:nvPr>
+            <p:ph type="sldNum" sz="quarter" idx="10"/>
+          </p:nvPr>
+        </p:nvSpPr>
+        <p:spPr/>
+        <p:txBody>
+          <a:bodyPr/>
+          <a:lstStyle/>
+          <a:p>
+            <a:fld id="{F7021451-1387-4CA6-816F-3879F97B5CBC}" type="slidenum">
+              <a:rPr lang="en-US"/>
+              <a:t>21</a:t>
             </a:fld>
             <a:endParaRPr lang="en-US"/>
           </a:p>
@@ -2737,7 +2915,7 @@
                 <a:ea typeface="Courier New" pitchFamily="34" charset="-122"/>
                 <a:cs typeface="Courier New" pitchFamily="34" charset="-120"/>
               </a:rPr>
-              <a:t>10 / 18   Smart-RUDP</a:t>
+              <a:t>10 / 20   Smart-RUDP</a:t>
             </a:r>
             <a:endParaRPr lang="en-US" sz="1000" dirty="0"/>
           </a:p>
@@ -2934,7 +3112,7 @@
                 <a:ea typeface="Courier New" pitchFamily="34" charset="-122"/>
                 <a:cs typeface="Courier New" pitchFamily="34" charset="-120"/>
               </a:rPr>
-              <a:t>11 / 18   Smart-RUDP</a:t>
+              <a:t>11 / 20   Smart-RUDP</a:t>
             </a:r>
             <a:endParaRPr lang="en-US" sz="1000" dirty="0"/>
           </a:p>
@@ -3764,7 +3942,7 @@
                 <a:ea typeface="Courier New" pitchFamily="34" charset="-122"/>
                 <a:cs typeface="Courier New" pitchFamily="34" charset="-120"/>
               </a:rPr>
-              <a:t>12 / 18   Smart-RUDP</a:t>
+              <a:t>12 / 20   Smart-RUDP</a:t>
             </a:r>
             <a:endParaRPr lang="en-US" sz="1000" dirty="0"/>
           </a:p>
@@ -4040,7 +4218,7 @@
                 <a:ea typeface="Courier New" pitchFamily="34" charset="-122"/>
                 <a:cs typeface="Courier New" pitchFamily="34" charset="-120"/>
               </a:rPr>
-              <a:t>13 / 18   Smart-RUDP</a:t>
+              <a:t>13 / 20   Smart-RUDP</a:t>
             </a:r>
             <a:endParaRPr lang="en-US" sz="1000" dirty="0"/>
           </a:p>
@@ -4301,7 +4479,7 @@
                 <a:ea typeface="Courier New" pitchFamily="34" charset="-122"/>
                 <a:cs typeface="Courier New" pitchFamily="34" charset="-120"/>
               </a:rPr>
-              <a:t>Smart-RUDP: a Q-learning window controller</a:t>
+              <a:t>Packet Tracer results: routes, failover, ACL</a:t>
             </a:r>
             <a:endParaRPr lang="en-US" sz="3000" dirty="0"/>
           </a:p>
@@ -4340,47 +4518,94 @@
                 <a:ea typeface="Courier New" pitchFamily="34" charset="-122"/>
                 <a:cs typeface="Courier New" pitchFamily="34" charset="-120"/>
               </a:rPr>
-              <a:t>14 / 18   Smart-RUDP</a:t>
+              <a:t>14 / 20   Smart-RUDP</a:t>
             </a:r>
             <a:endParaRPr lang="en-US" sz="1000" dirty="0"/>
           </a:p>
         </p:txBody>
       </p:sp>
-      <p:sp>
-        <p:nvSpPr>
-          <p:cNvPr id="4" name="Shape 2"/>
-          <p:cNvSpPr/>
-          <p:nvPr/>
-        </p:nvSpPr>
-        <p:spPr>
-          <a:xfrm>
-            <a:off x="548640" y="1371600"/>
-            <a:ext cx="3566160" cy="3108960"/>
-          </a:xfrm>
-          <a:prstGeom prst="rect">
-            <a:avLst/>
-          </a:prstGeom>
-          <a:solidFill>
-            <a:srgbClr val="141B24"/>
-          </a:solidFill>
-          <a:ln w="12700">
-            <a:solidFill>
-              <a:srgbClr val="39FF88"/>
-            </a:solidFill>
-            <a:prstDash val="solid"/>
-          </a:ln>
-        </p:spPr>
-      </p:sp>
-      <p:sp>
-        <p:nvSpPr>
-          <p:cNvPr id="5" name="Text 3"/>
-          <p:cNvSpPr/>
-          <p:nvPr/>
-        </p:nvSpPr>
-        <p:spPr>
-          <a:xfrm>
-            <a:off x="731520" y="1508760"/>
-            <a:ext cx="3200400" cy="457200"/>
+      <p:pic>
+        <p:nvPicPr>
+          <p:cNvPr id="4" name="Image 0" descr="pt_route.png">    </p:cNvPr>
+          <p:cNvPicPr>
+            <a:picLocks noChangeAspect="1"/>
+          </p:cNvPicPr>
+          <p:nvPr/>
+        </p:nvPicPr>
+        <p:blipFill>
+          <a:blip r:embed="rId1"/>
+          <a:stretch>
+            <a:fillRect/>
+          </a:stretch>
+        </p:blipFill>
+        <p:spPr>
+          <a:xfrm>
+            <a:off x="548640" y="1097280"/>
+            <a:ext cx="3584448" cy="3017520"/>
+          </a:xfrm>
+          <a:prstGeom prst="rect">
+            <a:avLst/>
+          </a:prstGeom>
+        </p:spPr>
+      </p:pic>
+      <p:pic>
+        <p:nvPicPr>
+          <p:cNvPr id="5" name="Image 1" descr="pt_failover.png">    </p:cNvPr>
+          <p:cNvPicPr>
+            <a:picLocks noChangeAspect="1"/>
+          </p:cNvPicPr>
+          <p:nvPr/>
+        </p:nvPicPr>
+        <p:blipFill>
+          <a:blip r:embed="rId2"/>
+          <a:stretch>
+            <a:fillRect/>
+          </a:stretch>
+        </p:blipFill>
+        <p:spPr>
+          <a:xfrm>
+            <a:off x="4297680" y="1097280"/>
+            <a:ext cx="3017520" cy="3017520"/>
+          </a:xfrm>
+          <a:prstGeom prst="rect">
+            <a:avLst/>
+          </a:prstGeom>
+        </p:spPr>
+      </p:pic>
+      <p:pic>
+        <p:nvPicPr>
+          <p:cNvPr id="6" name="Image 2" descr="pt_acl.png">    </p:cNvPr>
+          <p:cNvPicPr>
+            <a:picLocks noChangeAspect="1"/>
+          </p:cNvPicPr>
+          <p:nvPr/>
+        </p:nvPicPr>
+        <p:blipFill>
+          <a:blip r:embed="rId3"/>
+          <a:stretch>
+            <a:fillRect/>
+          </a:stretch>
+        </p:blipFill>
+        <p:spPr>
+          <a:xfrm>
+            <a:off x="7498080" y="1097280"/>
+            <a:ext cx="4023360" cy="3017520"/>
+          </a:xfrm>
+          <a:prstGeom prst="rect">
+            <a:avLst/>
+          </a:prstGeom>
+        </p:spPr>
+      </p:pic>
+      <p:sp>
+        <p:nvSpPr>
+          <p:cNvPr id="7" name="Text 2"/>
+          <p:cNvSpPr/>
+          <p:nvPr/>
+        </p:nvSpPr>
+        <p:spPr>
+          <a:xfrm>
+            <a:off x="548640" y="4206240"/>
+            <a:ext cx="3566160" cy="365760"/>
           </a:xfrm>
           <a:prstGeom prst="rect">
             <a:avLst/>
@@ -4396,30 +4621,108 @@
               <a:buNone/>
             </a:pPr>
             <a:r>
-              <a:rPr lang="en-US" sz="2000" b="1" dirty="0">
-                <a:solidFill>
-                  <a:srgbClr val="39FF88"/>
+              <a:rPr lang="en-US" sz="1400" dirty="0">
+                <a:solidFill>
+                  <a:srgbClr val="FFB000"/>
                 </a:solidFill>
                 <a:latin typeface="Courier New" pitchFamily="34" charset="0"/>
                 <a:ea typeface="Courier New" pitchFamily="34" charset="-122"/>
                 <a:cs typeface="Courier New" pitchFamily="34" charset="-120"/>
               </a:rPr>
-              <a:t>State (80)</a:t>
-            </a:r>
-            <a:endParaRPr lang="en-US" sz="2000" dirty="0"/>
-          </a:p>
-        </p:txBody>
-      </p:sp>
-      <p:sp>
-        <p:nvSpPr>
-          <p:cNvPr id="6" name="Text 4"/>
-          <p:cNvSpPr/>
-          <p:nvPr/>
-        </p:nvSpPr>
-        <p:spPr>
-          <a:xfrm>
-            <a:off x="731520" y="2011680"/>
-            <a:ext cx="3200400" cy="2331720"/>
+              <a:t>OSPF routes on R1</a:t>
+            </a:r>
+            <a:endParaRPr lang="en-US" sz="1400" dirty="0"/>
+          </a:p>
+        </p:txBody>
+      </p:sp>
+      <p:sp>
+        <p:nvSpPr>
+          <p:cNvPr id="8" name="Text 3"/>
+          <p:cNvSpPr/>
+          <p:nvPr/>
+        </p:nvSpPr>
+        <p:spPr>
+          <a:xfrm>
+            <a:off x="4297680" y="4206240"/>
+            <a:ext cx="3108960" cy="365760"/>
+          </a:xfrm>
+          <a:prstGeom prst="rect">
+            <a:avLst/>
+          </a:prstGeom>
+          <a:noFill/>
+          <a:ln/>
+        </p:spPr>
+        <p:txBody>
+          <a:bodyPr wrap="square" lIns="0" tIns="0" rIns="0" bIns="0" rtlCol="0" anchor="ctr"/>
+          <a:lstStyle/>
+          <a:p>
+            <a:pPr indent="0" marL="0">
+              <a:buNone/>
+            </a:pPr>
+            <a:r>
+              <a:rPr lang="en-US" sz="1400" dirty="0">
+                <a:solidFill>
+                  <a:srgbClr val="FFB000"/>
+                </a:solidFill>
+                <a:latin typeface="Courier New" pitchFamily="34" charset="0"/>
+                <a:ea typeface="Courier New" pitchFamily="34" charset="-122"/>
+                <a:cs typeface="Courier New" pitchFamily="34" charset="-120"/>
+              </a:rPr>
+              <a:t>Link failure: 70/71 pings, reroute</a:t>
+            </a:r>
+            <a:endParaRPr lang="en-US" sz="1400" dirty="0"/>
+          </a:p>
+        </p:txBody>
+      </p:sp>
+      <p:sp>
+        <p:nvSpPr>
+          <p:cNvPr id="9" name="Text 4"/>
+          <p:cNvSpPr/>
+          <p:nvPr/>
+        </p:nvSpPr>
+        <p:spPr>
+          <a:xfrm>
+            <a:off x="7498080" y="4206240"/>
+            <a:ext cx="4023360" cy="365760"/>
+          </a:xfrm>
+          <a:prstGeom prst="rect">
+            <a:avLst/>
+          </a:prstGeom>
+          <a:noFill/>
+          <a:ln/>
+        </p:spPr>
+        <p:txBody>
+          <a:bodyPr wrap="square" lIns="0" tIns="0" rIns="0" bIns="0" rtlCol="0" anchor="ctr"/>
+          <a:lstStyle/>
+          <a:p>
+            <a:pPr indent="0" marL="0">
+              <a:buNone/>
+            </a:pPr>
+            <a:r>
+              <a:rPr lang="en-US" sz="1400" dirty="0">
+                <a:solidFill>
+                  <a:srgbClr val="FFB000"/>
+                </a:solidFill>
+                <a:latin typeface="Courier New" pitchFamily="34" charset="0"/>
+                <a:ea typeface="Courier New" pitchFamily="34" charset="-122"/>
+                <a:cs typeface="Courier New" pitchFamily="34" charset="-120"/>
+              </a:rPr>
+              <a:t>ACL: student blocked, staff allowed</a:t>
+            </a:r>
+            <a:endParaRPr lang="en-US" sz="1400" dirty="0"/>
+          </a:p>
+        </p:txBody>
+      </p:sp>
+      <p:sp>
+        <p:nvSpPr>
+          <p:cNvPr id="10" name="Text 5"/>
+          <p:cNvSpPr/>
+          <p:nvPr/>
+        </p:nvSpPr>
+        <p:spPr>
+          <a:xfrm>
+            <a:off x="548640" y="4754880"/>
+            <a:ext cx="11064240" cy="1463040"/>
           </a:xfrm>
           <a:prstGeom prst="rect">
             <a:avLst/>
@@ -4431,11 +4734,15 @@
           <a:bodyPr wrap="square" lIns="0" tIns="0" rIns="0" bIns="0" rtlCol="0" anchor="t"/>
           <a:lstStyle/>
           <a:p>
-            <a:pPr indent="0" marL="0">
-              <a:buNone/>
-            </a:pPr>
-            <a:r>
-              <a:rPr lang="en-US" sz="2000" dirty="0">
+            <a:pPr marL="342900" indent="-342900">
+              <a:spcAft>
+                <a:spcPts val="800"/>
+              </a:spcAft>
+              <a:buSzPct val="100000"/>
+              <a:buChar char="•"/>
+            </a:pPr>
+            <a:r>
+              <a:rPr lang="en-US" sz="1700" dirty="0">
                 <a:solidFill>
                   <a:srgbClr val="E6EDF3"/>
                 </a:solidFill>
@@ -4443,102 +4750,20 @@
                 <a:ea typeface="Calibri" pitchFamily="34" charset="-122"/>
                 <a:cs typeface="Calibri" pitchFamily="34" charset="-120"/>
               </a:rPr>
-              <a:t>RTT ratio x loss fraction x window size, sampled once per RTT.</a:t>
-            </a:r>
-            <a:endParaRPr lang="en-US" sz="2000" dirty="0"/>
-          </a:p>
-        </p:txBody>
-      </p:sp>
-      <p:sp>
-        <p:nvSpPr>
-          <p:cNvPr id="7" name="Shape 5"/>
-          <p:cNvSpPr/>
-          <p:nvPr/>
-        </p:nvSpPr>
-        <p:spPr>
-          <a:xfrm>
-            <a:off x="4297680" y="1371600"/>
-            <a:ext cx="3566160" cy="3108960"/>
-          </a:xfrm>
-          <a:prstGeom prst="rect">
-            <a:avLst/>
-          </a:prstGeom>
-          <a:solidFill>
-            <a:srgbClr val="141B24"/>
-          </a:solidFill>
-          <a:ln w="12700">
-            <a:solidFill>
-              <a:srgbClr val="FFB000"/>
-            </a:solidFill>
-            <a:prstDash val="solid"/>
-          </a:ln>
-        </p:spPr>
-      </p:sp>
-      <p:sp>
-        <p:nvSpPr>
-          <p:cNvPr id="8" name="Text 6"/>
-          <p:cNvSpPr/>
-          <p:nvPr/>
-        </p:nvSpPr>
-        <p:spPr>
-          <a:xfrm>
-            <a:off x="4480560" y="1508760"/>
-            <a:ext cx="3200400" cy="457200"/>
-          </a:xfrm>
-          <a:prstGeom prst="rect">
-            <a:avLst/>
-          </a:prstGeom>
-          <a:noFill/>
-          <a:ln/>
-        </p:spPr>
-        <p:txBody>
-          <a:bodyPr wrap="square" lIns="0" tIns="0" rIns="0" bIns="0" rtlCol="0" anchor="ctr"/>
-          <a:lstStyle/>
-          <a:p>
-            <a:pPr indent="0" marL="0">
-              <a:buNone/>
-            </a:pPr>
-            <a:r>
-              <a:rPr lang="en-US" sz="2000" b="1" dirty="0">
-                <a:solidFill>
-                  <a:srgbClr val="FFB000"/>
-                </a:solidFill>
-                <a:latin typeface="Courier New" pitchFamily="34" charset="0"/>
-                <a:ea typeface="Courier New" pitchFamily="34" charset="-122"/>
-                <a:cs typeface="Courier New" pitchFamily="34" charset="-120"/>
-              </a:rPr>
-              <a:t>Action (5)</a:t>
-            </a:r>
-            <a:endParaRPr lang="en-US" sz="2000" dirty="0"/>
-          </a:p>
-        </p:txBody>
-      </p:sp>
-      <p:sp>
-        <p:nvSpPr>
-          <p:cNvPr id="9" name="Text 7"/>
-          <p:cNvSpPr/>
-          <p:nvPr/>
-        </p:nvSpPr>
-        <p:spPr>
-          <a:xfrm>
-            <a:off x="4480560" y="2011680"/>
-            <a:ext cx="3200400" cy="2331720"/>
-          </a:xfrm>
-          <a:prstGeom prst="rect">
-            <a:avLst/>
-          </a:prstGeom>
-          <a:noFill/>
-          <a:ln/>
-        </p:spPr>
-        <p:txBody>
-          <a:bodyPr wrap="square" lIns="0" tIns="0" rIns="0" bIns="0" rtlCol="0" anchor="t"/>
-          <a:lstStyle/>
-          <a:p>
-            <a:pPr indent="0" marL="0">
-              <a:buNone/>
-            </a:pPr>
-            <a:r>
-              <a:rPr lang="en-US" sz="2000" dirty="0">
+              <a:t>Server LAN metric 2 via R3, branch LAN metric 3 via R2</a:t>
+            </a:r>
+            <a:endParaRPr lang="en-US" sz="1700" dirty="0"/>
+          </a:p>
+          <a:p>
+            <a:pPr marL="342900" indent="-342900">
+              <a:spcAft>
+                <a:spcPts val="800"/>
+              </a:spcAft>
+              <a:buSzPct val="100000"/>
+              <a:buChar char="•"/>
+            </a:pPr>
+            <a:r>
+              <a:rPr lang="en-US" sz="1700" dirty="0">
                 <a:solidFill>
                   <a:srgbClr val="E6EDF3"/>
                 </a:solidFill>
@@ -4546,102 +4771,20 @@
                 <a:ea typeface="Calibri" pitchFamily="34" charset="-122"/>
                 <a:cs typeface="Calibri" pitchFamily="34" charset="-120"/>
               </a:rPr>
-              <a:t>Multiply cwnd by 0.5, 0.85, 1.0, 1.15 or 1.5.</a:t>
-            </a:r>
-            <a:endParaRPr lang="en-US" sz="2000" dirty="0"/>
-          </a:p>
-        </p:txBody>
-      </p:sp>
-      <p:sp>
-        <p:nvSpPr>
-          <p:cNvPr id="10" name="Shape 8"/>
-          <p:cNvSpPr/>
-          <p:nvPr/>
-        </p:nvSpPr>
-        <p:spPr>
-          <a:xfrm>
-            <a:off x="8046720" y="1371600"/>
-            <a:ext cx="3566160" cy="3108960"/>
-          </a:xfrm>
-          <a:prstGeom prst="rect">
-            <a:avLst/>
-          </a:prstGeom>
-          <a:solidFill>
-            <a:srgbClr val="141B24"/>
-          </a:solidFill>
-          <a:ln w="12700">
-            <a:solidFill>
-              <a:srgbClr val="39FF88"/>
-            </a:solidFill>
-            <a:prstDash val="solid"/>
-          </a:ln>
-        </p:spPr>
-      </p:sp>
-      <p:sp>
-        <p:nvSpPr>
-          <p:cNvPr id="11" name="Text 9"/>
-          <p:cNvSpPr/>
-          <p:nvPr/>
-        </p:nvSpPr>
-        <p:spPr>
-          <a:xfrm>
-            <a:off x="8229600" y="1508760"/>
-            <a:ext cx="3200400" cy="457200"/>
-          </a:xfrm>
-          <a:prstGeom prst="rect">
-            <a:avLst/>
-          </a:prstGeom>
-          <a:noFill/>
-          <a:ln/>
-        </p:spPr>
-        <p:txBody>
-          <a:bodyPr wrap="square" lIns="0" tIns="0" rIns="0" bIns="0" rtlCol="0" anchor="ctr"/>
-          <a:lstStyle/>
-          <a:p>
-            <a:pPr indent="0" marL="0">
-              <a:buNone/>
-            </a:pPr>
-            <a:r>
-              <a:rPr lang="en-US" sz="2000" b="1" dirty="0">
-                <a:solidFill>
-                  <a:srgbClr val="39FF88"/>
-                </a:solidFill>
-                <a:latin typeface="Courier New" pitchFamily="34" charset="0"/>
-                <a:ea typeface="Courier New" pitchFamily="34" charset="-122"/>
-                <a:cs typeface="Courier New" pitchFamily="34" charset="-120"/>
-              </a:rPr>
-              <a:t>Reward</a:t>
-            </a:r>
-            <a:endParaRPr lang="en-US" sz="2000" dirty="0"/>
-          </a:p>
-        </p:txBody>
-      </p:sp>
-      <p:sp>
-        <p:nvSpPr>
-          <p:cNvPr id="12" name="Text 10"/>
-          <p:cNvSpPr/>
-          <p:nvPr/>
-        </p:nvSpPr>
-        <p:spPr>
-          <a:xfrm>
-            <a:off x="8229600" y="2011680"/>
-            <a:ext cx="3200400" cy="2331720"/>
-          </a:xfrm>
-          <a:prstGeom prst="rect">
-            <a:avLst/>
-          </a:prstGeom>
-          <a:noFill/>
-          <a:ln/>
-        </p:spPr>
-        <p:txBody>
-          <a:bodyPr wrap="square" lIns="0" tIns="0" rIns="0" bIns="0" rtlCol="0" anchor="t"/>
-          <a:lstStyle/>
-          <a:p>
-            <a:pPr indent="0" marL="0">
-              <a:buNone/>
-            </a:pPr>
-            <a:r>
-              <a:rPr lang="en-US" sz="2000" dirty="0">
+              <a:t>Shutting R1 Gi0/2: traffic reroutes via R2, only 1 of 71 pings lost</a:t>
+            </a:r>
+            <a:endParaRPr lang="en-US" sz="1700" dirty="0"/>
+          </a:p>
+          <a:p>
+            <a:pPr marL="342900" indent="-342900">
+              <a:spcAft>
+                <a:spcPts val="800"/>
+              </a:spcAft>
+              <a:buSzPct val="100000"/>
+              <a:buChar char="•"/>
+            </a:pPr>
+            <a:r>
+              <a:rPr lang="en-US" sz="1700" dirty="0">
                 <a:solidFill>
                   <a:srgbClr val="E6EDF3"/>
                 </a:solidFill>
@@ -4649,48 +4792,9 @@
                 <a:ea typeface="Calibri" pitchFamily="34" charset="-122"/>
                 <a:cs typeface="Calibri" pitchFamily="34" charset="-120"/>
               </a:rPr>
-              <a:t>Throughput gained, minus delay growth, minus retransmissions.</a:t>
-            </a:r>
-            <a:endParaRPr lang="en-US" sz="2000" dirty="0"/>
-          </a:p>
-        </p:txBody>
-      </p:sp>
-      <p:sp>
-        <p:nvSpPr>
-          <p:cNvPr id="13" name="Text 11"/>
-          <p:cNvSpPr/>
-          <p:nvPr/>
-        </p:nvSpPr>
-        <p:spPr>
-          <a:xfrm>
-            <a:off x="548640" y="4846320"/>
-            <a:ext cx="10972800" cy="914400"/>
-          </a:xfrm>
-          <a:prstGeom prst="rect">
-            <a:avLst/>
-          </a:prstGeom>
-          <a:noFill/>
-          <a:ln/>
-        </p:spPr>
-        <p:txBody>
-          <a:bodyPr wrap="square" lIns="0" tIns="0" rIns="0" bIns="0" rtlCol="0" anchor="ctr"/>
-          <a:lstStyle/>
-          <a:p>
-            <a:pPr indent="0" marL="0">
-              <a:buNone/>
-            </a:pPr>
-            <a:r>
-              <a:rPr lang="en-US" sz="1800" dirty="0">
-                <a:solidFill>
-                  <a:srgbClr val="E6EDF3"/>
-                </a:solidFill>
-                <a:latin typeface="Calibri" pitchFamily="34" charset="0"/>
-                <a:ea typeface="Calibri" pitchFamily="34" charset="-122"/>
-                <a:cs typeface="Calibri" pitchFamily="34" charset="-120"/>
-              </a:rPr>
-              <a:t>Same Go-Back-N reliability as the baseline; only the window policy changes. Paths emulated in-program: 5G-like, lossy wireless, satellite-like.</a:t>
-            </a:r>
-            <a:endParaRPr lang="en-US" sz="1800" dirty="0"/>
+              <a:t>Student PC gets "destination unreachable" to staff; server still reachable (TTL 126)</a:t>
+            </a:r>
+            <a:endParaRPr lang="en-US" sz="1700" dirty="0"/>
           </a:p>
         </p:txBody>
       </p:sp>
@@ -4759,7 +4863,7 @@
                 <a:ea typeface="Courier New" pitchFamily="34" charset="-122"/>
                 <a:cs typeface="Courier New" pitchFamily="34" charset="-120"/>
               </a:rPr>
-              <a:t>Smart-RUDP vs AIMD: honest result</a:t>
+              <a:t>Smart-RUDP: a Q-learning window controller</a:t>
             </a:r>
             <a:endParaRPr lang="en-US" sz="3000" dirty="0"/>
           </a:p>
@@ -4798,46 +4902,86 @@
                 <a:ea typeface="Courier New" pitchFamily="34" charset="-122"/>
                 <a:cs typeface="Courier New" pitchFamily="34" charset="-120"/>
               </a:rPr>
-              <a:t>15 / 18   Smart-RUDP</a:t>
+              <a:t>15 / 20   Smart-RUDP</a:t>
             </a:r>
             <a:endParaRPr lang="en-US" sz="1000" dirty="0"/>
           </a:p>
         </p:txBody>
       </p:sp>
-      <p:pic>
-        <p:nvPicPr>
-          <p:cNvPr id="4" name="Image 0" descr="sm_fig1_comparison.png">    </p:cNvPr>
-          <p:cNvPicPr>
-            <a:picLocks noChangeAspect="1"/>
-          </p:cNvPicPr>
-          <p:nvPr/>
-        </p:nvPicPr>
-        <p:blipFill>
-          <a:blip r:embed="rId1"/>
-          <a:stretch>
-            <a:fillRect/>
-          </a:stretch>
-        </p:blipFill>
-        <p:spPr>
-          <a:xfrm>
-            <a:off x="548640" y="1097280"/>
-            <a:ext cx="11064240" cy="3621024"/>
-          </a:xfrm>
-          <a:prstGeom prst="rect">
-            <a:avLst/>
-          </a:prstGeom>
-        </p:spPr>
-      </p:pic>
-      <p:sp>
-        <p:nvSpPr>
-          <p:cNvPr id="5" name="Text 2"/>
-          <p:cNvSpPr/>
-          <p:nvPr/>
-        </p:nvSpPr>
-        <p:spPr>
-          <a:xfrm>
-            <a:off x="548640" y="4937760"/>
-            <a:ext cx="11064240" cy="1463040"/>
+      <p:sp>
+        <p:nvSpPr>
+          <p:cNvPr id="4" name="Shape 2"/>
+          <p:cNvSpPr/>
+          <p:nvPr/>
+        </p:nvSpPr>
+        <p:spPr>
+          <a:xfrm>
+            <a:off x="548640" y="1371600"/>
+            <a:ext cx="3566160" cy="3108960"/>
+          </a:xfrm>
+          <a:prstGeom prst="rect">
+            <a:avLst/>
+          </a:prstGeom>
+          <a:solidFill>
+            <a:srgbClr val="141B24"/>
+          </a:solidFill>
+          <a:ln w="12700">
+            <a:solidFill>
+              <a:srgbClr val="39FF88"/>
+            </a:solidFill>
+            <a:prstDash val="solid"/>
+          </a:ln>
+        </p:spPr>
+      </p:sp>
+      <p:sp>
+        <p:nvSpPr>
+          <p:cNvPr id="5" name="Text 3"/>
+          <p:cNvSpPr/>
+          <p:nvPr/>
+        </p:nvSpPr>
+        <p:spPr>
+          <a:xfrm>
+            <a:off x="731520" y="1508760"/>
+            <a:ext cx="3200400" cy="457200"/>
+          </a:xfrm>
+          <a:prstGeom prst="rect">
+            <a:avLst/>
+          </a:prstGeom>
+          <a:noFill/>
+          <a:ln/>
+        </p:spPr>
+        <p:txBody>
+          <a:bodyPr wrap="square" lIns="0" tIns="0" rIns="0" bIns="0" rtlCol="0" anchor="ctr"/>
+          <a:lstStyle/>
+          <a:p>
+            <a:pPr indent="0" marL="0">
+              <a:buNone/>
+            </a:pPr>
+            <a:r>
+              <a:rPr lang="en-US" sz="2000" b="1" dirty="0">
+                <a:solidFill>
+                  <a:srgbClr val="39FF88"/>
+                </a:solidFill>
+                <a:latin typeface="Courier New" pitchFamily="34" charset="0"/>
+                <a:ea typeface="Courier New" pitchFamily="34" charset="-122"/>
+                <a:cs typeface="Courier New" pitchFamily="34" charset="-120"/>
+              </a:rPr>
+              <a:t>State (80)</a:t>
+            </a:r>
+            <a:endParaRPr lang="en-US" sz="2000" dirty="0"/>
+          </a:p>
+        </p:txBody>
+      </p:sp>
+      <p:sp>
+        <p:nvSpPr>
+          <p:cNvPr id="6" name="Text 4"/>
+          <p:cNvSpPr/>
+          <p:nvPr/>
+        </p:nvSpPr>
+        <p:spPr>
+          <a:xfrm>
+            <a:off x="731520" y="2011680"/>
+            <a:ext cx="3200400" cy="2331720"/>
           </a:xfrm>
           <a:prstGeom prst="rect">
             <a:avLst/>
@@ -4849,15 +4993,11 @@
           <a:bodyPr wrap="square" lIns="0" tIns="0" rIns="0" bIns="0" rtlCol="0" anchor="t"/>
           <a:lstStyle/>
           <a:p>
-            <a:pPr marL="342900" indent="-342900">
-              <a:spcAft>
-                <a:spcPts val="800"/>
-              </a:spcAft>
-              <a:buSzPct val="100000"/>
-              <a:buChar char="•"/>
-            </a:pPr>
-            <a:r>
-              <a:rPr lang="en-US" sz="1500" dirty="0">
+            <a:pPr indent="0" marL="0">
+              <a:buNone/>
+            </a:pPr>
+            <a:r>
+              <a:rPr lang="en-US" sz="2000" dirty="0">
                 <a:solidFill>
                   <a:srgbClr val="E6EDF3"/>
                 </a:solidFill>
@@ -4865,20 +5005,102 @@
                 <a:ea typeface="Calibri" pitchFamily="34" charset="-122"/>
                 <a:cs typeface="Calibri" pitchFamily="34" charset="-120"/>
               </a:rPr>
-              <a:t>6 evaluation runs per scenario after 40 training episodes</a:t>
-            </a:r>
-            <a:endParaRPr lang="en-US" sz="1500" dirty="0"/>
-          </a:p>
-          <a:p>
-            <a:pPr marL="342900" indent="-342900">
-              <a:spcAft>
-                <a:spcPts val="800"/>
-              </a:spcAft>
-              <a:buSzPct val="100000"/>
-              <a:buChar char="•"/>
-            </a:pPr>
-            <a:r>
-              <a:rPr lang="en-US" sz="1500" dirty="0">
+              <a:t>RTT ratio x loss fraction x window size, sampled once per RTT.</a:t>
+            </a:r>
+            <a:endParaRPr lang="en-US" sz="2000" dirty="0"/>
+          </a:p>
+        </p:txBody>
+      </p:sp>
+      <p:sp>
+        <p:nvSpPr>
+          <p:cNvPr id="7" name="Shape 5"/>
+          <p:cNvSpPr/>
+          <p:nvPr/>
+        </p:nvSpPr>
+        <p:spPr>
+          <a:xfrm>
+            <a:off x="4297680" y="1371600"/>
+            <a:ext cx="3566160" cy="3108960"/>
+          </a:xfrm>
+          <a:prstGeom prst="rect">
+            <a:avLst/>
+          </a:prstGeom>
+          <a:solidFill>
+            <a:srgbClr val="141B24"/>
+          </a:solidFill>
+          <a:ln w="12700">
+            <a:solidFill>
+              <a:srgbClr val="FFB000"/>
+            </a:solidFill>
+            <a:prstDash val="solid"/>
+          </a:ln>
+        </p:spPr>
+      </p:sp>
+      <p:sp>
+        <p:nvSpPr>
+          <p:cNvPr id="8" name="Text 6"/>
+          <p:cNvSpPr/>
+          <p:nvPr/>
+        </p:nvSpPr>
+        <p:spPr>
+          <a:xfrm>
+            <a:off x="4480560" y="1508760"/>
+            <a:ext cx="3200400" cy="457200"/>
+          </a:xfrm>
+          <a:prstGeom prst="rect">
+            <a:avLst/>
+          </a:prstGeom>
+          <a:noFill/>
+          <a:ln/>
+        </p:spPr>
+        <p:txBody>
+          <a:bodyPr wrap="square" lIns="0" tIns="0" rIns="0" bIns="0" rtlCol="0" anchor="ctr"/>
+          <a:lstStyle/>
+          <a:p>
+            <a:pPr indent="0" marL="0">
+              <a:buNone/>
+            </a:pPr>
+            <a:r>
+              <a:rPr lang="en-US" sz="2000" b="1" dirty="0">
+                <a:solidFill>
+                  <a:srgbClr val="FFB000"/>
+                </a:solidFill>
+                <a:latin typeface="Courier New" pitchFamily="34" charset="0"/>
+                <a:ea typeface="Courier New" pitchFamily="34" charset="-122"/>
+                <a:cs typeface="Courier New" pitchFamily="34" charset="-120"/>
+              </a:rPr>
+              <a:t>Action (5)</a:t>
+            </a:r>
+            <a:endParaRPr lang="en-US" sz="2000" dirty="0"/>
+          </a:p>
+        </p:txBody>
+      </p:sp>
+      <p:sp>
+        <p:nvSpPr>
+          <p:cNvPr id="9" name="Text 7"/>
+          <p:cNvSpPr/>
+          <p:nvPr/>
+        </p:nvSpPr>
+        <p:spPr>
+          <a:xfrm>
+            <a:off x="4480560" y="2011680"/>
+            <a:ext cx="3200400" cy="2331720"/>
+          </a:xfrm>
+          <a:prstGeom prst="rect">
+            <a:avLst/>
+          </a:prstGeom>
+          <a:noFill/>
+          <a:ln/>
+        </p:spPr>
+        <p:txBody>
+          <a:bodyPr wrap="square" lIns="0" tIns="0" rIns="0" bIns="0" rtlCol="0" anchor="t"/>
+          <a:lstStyle/>
+          <a:p>
+            <a:pPr indent="0" marL="0">
+              <a:buNone/>
+            </a:pPr>
+            <a:r>
+              <a:rPr lang="en-US" sz="2000" dirty="0">
                 <a:solidFill>
                   <a:srgbClr val="E6EDF3"/>
                 </a:solidFill>
@@ -4886,20 +5108,102 @@
                 <a:ea typeface="Calibri" pitchFamily="34" charset="-122"/>
                 <a:cs typeface="Calibri" pitchFamily="34" charset="-120"/>
               </a:rPr>
-              <a:t>Not faster: +63% time on 5G-like, +10% on satellite, tie on lossy</a:t>
-            </a:r>
-            <a:endParaRPr lang="en-US" sz="1500" dirty="0"/>
-          </a:p>
-          <a:p>
-            <a:pPr marL="342900" indent="-342900">
-              <a:spcAft>
-                <a:spcPts val="800"/>
-              </a:spcAft>
-              <a:buSzPct val="100000"/>
-              <a:buChar char="•"/>
-            </a:pPr>
-            <a:r>
-              <a:rPr lang="en-US" sz="1500" dirty="0">
+              <a:t>Multiply cwnd by 0.5, 0.85, 1.0, 1.15 or 1.5.</a:t>
+            </a:r>
+            <a:endParaRPr lang="en-US" sz="2000" dirty="0"/>
+          </a:p>
+        </p:txBody>
+      </p:sp>
+      <p:sp>
+        <p:nvSpPr>
+          <p:cNvPr id="10" name="Shape 8"/>
+          <p:cNvSpPr/>
+          <p:nvPr/>
+        </p:nvSpPr>
+        <p:spPr>
+          <a:xfrm>
+            <a:off x="8046720" y="1371600"/>
+            <a:ext cx="3566160" cy="3108960"/>
+          </a:xfrm>
+          <a:prstGeom prst="rect">
+            <a:avLst/>
+          </a:prstGeom>
+          <a:solidFill>
+            <a:srgbClr val="141B24"/>
+          </a:solidFill>
+          <a:ln w="12700">
+            <a:solidFill>
+              <a:srgbClr val="39FF88"/>
+            </a:solidFill>
+            <a:prstDash val="solid"/>
+          </a:ln>
+        </p:spPr>
+      </p:sp>
+      <p:sp>
+        <p:nvSpPr>
+          <p:cNvPr id="11" name="Text 9"/>
+          <p:cNvSpPr/>
+          <p:nvPr/>
+        </p:nvSpPr>
+        <p:spPr>
+          <a:xfrm>
+            <a:off x="8229600" y="1508760"/>
+            <a:ext cx="3200400" cy="457200"/>
+          </a:xfrm>
+          <a:prstGeom prst="rect">
+            <a:avLst/>
+          </a:prstGeom>
+          <a:noFill/>
+          <a:ln/>
+        </p:spPr>
+        <p:txBody>
+          <a:bodyPr wrap="square" lIns="0" tIns="0" rIns="0" bIns="0" rtlCol="0" anchor="ctr"/>
+          <a:lstStyle/>
+          <a:p>
+            <a:pPr indent="0" marL="0">
+              <a:buNone/>
+            </a:pPr>
+            <a:r>
+              <a:rPr lang="en-US" sz="2000" b="1" dirty="0">
+                <a:solidFill>
+                  <a:srgbClr val="39FF88"/>
+                </a:solidFill>
+                <a:latin typeface="Courier New" pitchFamily="34" charset="0"/>
+                <a:ea typeface="Courier New" pitchFamily="34" charset="-122"/>
+                <a:cs typeface="Courier New" pitchFamily="34" charset="-120"/>
+              </a:rPr>
+              <a:t>Reward</a:t>
+            </a:r>
+            <a:endParaRPr lang="en-US" sz="2000" dirty="0"/>
+          </a:p>
+        </p:txBody>
+      </p:sp>
+      <p:sp>
+        <p:nvSpPr>
+          <p:cNvPr id="12" name="Text 10"/>
+          <p:cNvSpPr/>
+          <p:nvPr/>
+        </p:nvSpPr>
+        <p:spPr>
+          <a:xfrm>
+            <a:off x="8229600" y="2011680"/>
+            <a:ext cx="3200400" cy="2331720"/>
+          </a:xfrm>
+          <a:prstGeom prst="rect">
+            <a:avLst/>
+          </a:prstGeom>
+          <a:noFill/>
+          <a:ln/>
+        </p:spPr>
+        <p:txBody>
+          <a:bodyPr wrap="square" lIns="0" tIns="0" rIns="0" bIns="0" rtlCol="0" anchor="t"/>
+          <a:lstStyle/>
+          <a:p>
+            <a:pPr indent="0" marL="0">
+              <a:buNone/>
+            </a:pPr>
+            <a:r>
+              <a:rPr lang="en-US" sz="2000" dirty="0">
                 <a:solidFill>
                   <a:srgbClr val="E6EDF3"/>
                 </a:solidFill>
@@ -4907,20 +5211,38 @@
                 <a:ea typeface="Calibri" pitchFamily="34" charset="-122"/>
                 <a:cs typeface="Calibri" pitchFamily="34" charset="-120"/>
               </a:rPr>
-              <a:t>Fewer retransmissions on 5G-like and satellite, but within run-to-run noise</a:t>
-            </a:r>
-            <a:endParaRPr lang="en-US" sz="1500" dirty="0"/>
-          </a:p>
-          <a:p>
-            <a:pPr marL="342900" indent="-342900">
-              <a:spcAft>
-                <a:spcPts val="800"/>
-              </a:spcAft>
-              <a:buSzPct val="100000"/>
-              <a:buChar char="•"/>
-            </a:pPr>
-            <a:r>
-              <a:rPr lang="en-US" sz="1500" dirty="0">
+              <a:t>Throughput gained, minus delay growth, minus retransmissions.</a:t>
+            </a:r>
+            <a:endParaRPr lang="en-US" sz="2000" dirty="0"/>
+          </a:p>
+        </p:txBody>
+      </p:sp>
+      <p:sp>
+        <p:nvSpPr>
+          <p:cNvPr id="13" name="Text 11"/>
+          <p:cNvSpPr/>
+          <p:nvPr/>
+        </p:nvSpPr>
+        <p:spPr>
+          <a:xfrm>
+            <a:off x="548640" y="4846320"/>
+            <a:ext cx="10972800" cy="914400"/>
+          </a:xfrm>
+          <a:prstGeom prst="rect">
+            <a:avLst/>
+          </a:prstGeom>
+          <a:noFill/>
+          <a:ln/>
+        </p:spPr>
+        <p:txBody>
+          <a:bodyPr wrap="square" lIns="0" tIns="0" rIns="0" bIns="0" rtlCol="0" anchor="ctr"/>
+          <a:lstStyle/>
+          <a:p>
+            <a:pPr indent="0" marL="0">
+              <a:buNone/>
+            </a:pPr>
+            <a:r>
+              <a:rPr lang="en-US" sz="1800" dirty="0">
                 <a:solidFill>
                   <a:srgbClr val="E6EDF3"/>
                 </a:solidFill>
@@ -4928,9 +5250,9 @@
                 <a:ea typeface="Calibri" pitchFamily="34" charset="-122"/>
                 <a:cs typeface="Calibri" pitchFamily="34" charset="-120"/>
               </a:rPr>
-              <a:t>Earlier training rounds were much worse; reported run is the final configuration</a:t>
-            </a:r>
-            <a:endParaRPr lang="en-US" sz="1500" dirty="0"/>
+              <a:t>Same Go-Back-N reliability as the baseline; only the window policy changes. Paths emulated in-program: 5G-like, lossy wireless, satellite-like.</a:t>
+            </a:r>
+            <a:endParaRPr lang="en-US" sz="1800" dirty="0"/>
           </a:p>
         </p:txBody>
       </p:sp>
@@ -4999,7 +5321,7 @@
                 <a:ea typeface="Courier New" pitchFamily="34" charset="-122"/>
                 <a:cs typeface="Courier New" pitchFamily="34" charset="-120"/>
               </a:rPr>
-              <a:t>Wireshark: RUDP dissector and traces</a:t>
+              <a:t>Smart-RUDP vs AIMD: honest result</a:t>
             </a:r>
             <a:endParaRPr lang="en-US" sz="3000" dirty="0"/>
           </a:p>
@@ -5038,7 +5360,7 @@
                 <a:ea typeface="Courier New" pitchFamily="34" charset="-122"/>
                 <a:cs typeface="Courier New" pitchFamily="34" charset="-120"/>
               </a:rPr>
-              <a:t>16 / 18   Smart-RUDP</a:t>
+              <a:t>16 / 20   Smart-RUDP</a:t>
             </a:r>
             <a:endParaRPr lang="en-US" sz="1000" dirty="0"/>
           </a:p>
@@ -5046,7 +5368,7 @@
       </p:sp>
       <p:pic>
         <p:nvPicPr>
-          <p:cNvPr id="4" name="Image 0" descr="wireshark_seq_time.png">    </p:cNvPr>
+          <p:cNvPr id="4" name="Image 0" descr="sm_fig1_comparison.png">    </p:cNvPr>
           <p:cNvPicPr>
             <a:picLocks noChangeAspect="1"/>
           </p:cNvPicPr>
@@ -5061,7 +5383,7 @@
         <p:spPr>
           <a:xfrm>
             <a:off x="548640" y="1097280"/>
-            <a:ext cx="7863840" cy="2716599"/>
+            <a:ext cx="11064240" cy="3621024"/>
           </a:xfrm>
           <a:prstGeom prst="rect">
             <a:avLst/>
@@ -5076,8 +5398,8 @@
         </p:nvSpPr>
         <p:spPr>
           <a:xfrm>
-            <a:off x="8595360" y="1280160"/>
-            <a:ext cx="3200400" cy="4114800"/>
+            <a:off x="548640" y="4937760"/>
+            <a:ext cx="11064240" cy="1463040"/>
           </a:xfrm>
           <a:prstGeom prst="rect">
             <a:avLst/>
@@ -5097,7 +5419,7 @@
               <a:buChar char="•"/>
             </a:pPr>
             <a:r>
-              <a:rPr lang="en-US" sz="1400" dirty="0">
+              <a:rPr lang="en-US" sz="1500" dirty="0">
                 <a:solidFill>
                   <a:srgbClr val="E6EDF3"/>
                 </a:solidFill>
@@ -5105,9 +5427,9 @@
                 <a:ea typeface="Calibri" pitchFamily="34" charset="-122"/>
                 <a:cs typeface="Calibri" pitchFamily="34" charset="-120"/>
               </a:rPr>
-              <a:t>rudp.lua decodes seq, ack, flags, checksum, length</a:t>
-            </a:r>
-            <a:endParaRPr lang="en-US" sz="1400" dirty="0"/>
+              <a:t>6 evaluation runs per scenario after 40 training episodes</a:t>
+            </a:r>
+            <a:endParaRPr lang="en-US" sz="1500" dirty="0"/>
           </a:p>
           <a:p>
             <a:pPr marL="342900" indent="-342900">
@@ -5118,7 +5440,7 @@
               <a:buChar char="•"/>
             </a:pPr>
             <a:r>
-              <a:rPr lang="en-US" sz="1400" dirty="0">
+              <a:rPr lang="en-US" sz="1500" dirty="0">
                 <a:solidFill>
                   <a:srgbClr val="E6EDF3"/>
                 </a:solidFill>
@@ -5126,9 +5448,9 @@
                 <a:ea typeface="Calibri" pitchFamily="34" charset="-122"/>
                 <a:cs typeface="Calibri" pitchFamily="34" charset="-120"/>
               </a:rPr>
-              <a:t>Filters: smartrudp.flags.data == 1, smartrudp.seq == N</a:t>
-            </a:r>
-            <a:endParaRPr lang="en-US" sz="1400" dirty="0"/>
+              <a:t>Not faster: +63% time on 5G-like, +10% on satellite, tie on lossy</a:t>
+            </a:r>
+            <a:endParaRPr lang="en-US" sz="1500" dirty="0"/>
           </a:p>
           <a:p>
             <a:pPr marL="342900" indent="-342900">
@@ -5139,7 +5461,7 @@
               <a:buChar char="•"/>
             </a:pPr>
             <a:r>
-              <a:rPr lang="en-US" sz="1400" dirty="0">
+              <a:rPr lang="en-US" sz="1500" dirty="0">
                 <a:solidFill>
                   <a:srgbClr val="E6EDF3"/>
                 </a:solidFill>
@@ -5147,9 +5469,9 @@
                 <a:ea typeface="Calibri" pitchFamily="34" charset="-122"/>
                 <a:cs typeface="Calibri" pitchFamily="34" charset="-120"/>
               </a:rPr>
-              <a:t>400 packets, lossy path: 87 (AIMD) and 95 (Smart) repeated data segments seen at the receiver</a:t>
-            </a:r>
-            <a:endParaRPr lang="en-US" sz="1400" dirty="0"/>
+              <a:t>Fewer retransmissions on 5G-like and satellite, but within run-to-run noise</a:t>
+            </a:r>
+            <a:endParaRPr lang="en-US" sz="1500" dirty="0"/>
           </a:p>
           <a:p>
             <a:pPr marL="342900" indent="-342900">
@@ -5160,7 +5482,7 @@
               <a:buChar char="•"/>
             </a:pPr>
             <a:r>
-              <a:rPr lang="en-US" sz="1400" dirty="0">
+              <a:rPr lang="en-US" sz="1500" dirty="0">
                 <a:solidFill>
                   <a:srgbClr val="E6EDF3"/>
                 </a:solidFill>
@@ -5168,9 +5490,9 @@
                 <a:ea typeface="Calibri" pitchFamily="34" charset="-122"/>
                 <a:cs typeface="Calibri" pitchFamily="34" charset="-120"/>
               </a:rPr>
-              <a:t>Trace exported by the program, topology addresses, handshake not included</a:t>
-            </a:r>
-            <a:endParaRPr lang="en-US" sz="1400" dirty="0"/>
+              <a:t>Earlier training rounds were much worse; reported run is the final configuration</a:t>
+            </a:r>
+            <a:endParaRPr lang="en-US" sz="1500" dirty="0"/>
           </a:p>
         </p:txBody>
       </p:sp>
@@ -5239,7 +5561,7 @@
                 <a:ea typeface="Courier New" pitchFamily="34" charset="-122"/>
                 <a:cs typeface="Courier New" pitchFamily="34" charset="-120"/>
               </a:rPr>
-              <a:t>Learnings and future work</a:t>
+              <a:t>Wireshark: RUDP dissector and traces</a:t>
             </a:r>
             <a:endParaRPr lang="en-US" sz="3000" dirty="0"/>
           </a:p>
@@ -5278,86 +5600,46 @@
                 <a:ea typeface="Courier New" pitchFamily="34" charset="-122"/>
                 <a:cs typeface="Courier New" pitchFamily="34" charset="-120"/>
               </a:rPr>
-              <a:t>17 / 18   Smart-RUDP</a:t>
+              <a:t>17 / 20   Smart-RUDP</a:t>
             </a:r>
             <a:endParaRPr lang="en-US" sz="1000" dirty="0"/>
           </a:p>
         </p:txBody>
       </p:sp>
-      <p:sp>
-        <p:nvSpPr>
-          <p:cNvPr id="4" name="Shape 2"/>
-          <p:cNvSpPr/>
-          <p:nvPr/>
-        </p:nvSpPr>
-        <p:spPr>
-          <a:xfrm>
-            <a:off x="548640" y="1371600"/>
-            <a:ext cx="5394960" cy="4206240"/>
-          </a:xfrm>
-          <a:prstGeom prst="rect">
-            <a:avLst/>
-          </a:prstGeom>
-          <a:solidFill>
-            <a:srgbClr val="141B24"/>
-          </a:solidFill>
-          <a:ln w="12700">
-            <a:solidFill>
-              <a:srgbClr val="39FF88"/>
-            </a:solidFill>
-            <a:prstDash val="solid"/>
-          </a:ln>
-        </p:spPr>
-      </p:sp>
-      <p:sp>
-        <p:nvSpPr>
-          <p:cNvPr id="5" name="Text 3"/>
-          <p:cNvSpPr/>
-          <p:nvPr/>
-        </p:nvSpPr>
-        <p:spPr>
-          <a:xfrm>
-            <a:off x="731520" y="1508760"/>
-            <a:ext cx="5029200" cy="457200"/>
-          </a:xfrm>
-          <a:prstGeom prst="rect">
-            <a:avLst/>
-          </a:prstGeom>
-          <a:noFill/>
-          <a:ln/>
-        </p:spPr>
-        <p:txBody>
-          <a:bodyPr wrap="square" lIns="0" tIns="0" rIns="0" bIns="0" rtlCol="0" anchor="ctr"/>
-          <a:lstStyle/>
-          <a:p>
-            <a:pPr indent="0" marL="0">
-              <a:buNone/>
-            </a:pPr>
-            <a:r>
-              <a:rPr lang="en-US" sz="2000" b="1" dirty="0">
-                <a:solidFill>
-                  <a:srgbClr val="39FF88"/>
-                </a:solidFill>
-                <a:latin typeface="Courier New" pitchFamily="34" charset="0"/>
-                <a:ea typeface="Courier New" pitchFamily="34" charset="-122"/>
-                <a:cs typeface="Courier New" pitchFamily="34" charset="-120"/>
-              </a:rPr>
-              <a:t>Learned</a:t>
-            </a:r>
-            <a:endParaRPr lang="en-US" sz="2000" dirty="0"/>
-          </a:p>
-        </p:txBody>
-      </p:sp>
-      <p:sp>
-        <p:nvSpPr>
-          <p:cNvPr id="6" name="Text 4"/>
-          <p:cNvSpPr/>
-          <p:nvPr/>
-        </p:nvSpPr>
-        <p:spPr>
-          <a:xfrm>
-            <a:off x="731520" y="2011680"/>
-            <a:ext cx="5029200" cy="3429000"/>
+      <p:pic>
+        <p:nvPicPr>
+          <p:cNvPr id="4" name="Image 0" descr="wireshark_seq_time.png">    </p:cNvPr>
+          <p:cNvPicPr>
+            <a:picLocks noChangeAspect="1"/>
+          </p:cNvPicPr>
+          <p:nvPr/>
+        </p:nvPicPr>
+        <p:blipFill>
+          <a:blip r:embed="rId1"/>
+          <a:stretch>
+            <a:fillRect/>
+          </a:stretch>
+        </p:blipFill>
+        <p:spPr>
+          <a:xfrm>
+            <a:off x="548640" y="1097280"/>
+            <a:ext cx="7863840" cy="2716599"/>
+          </a:xfrm>
+          <a:prstGeom prst="rect">
+            <a:avLst/>
+          </a:prstGeom>
+        </p:spPr>
+      </p:pic>
+      <p:sp>
+        <p:nvSpPr>
+          <p:cNvPr id="5" name="Text 2"/>
+          <p:cNvSpPr/>
+          <p:nvPr/>
+        </p:nvSpPr>
+        <p:spPr>
+          <a:xfrm>
+            <a:off x="8595360" y="1280160"/>
+            <a:ext cx="3200400" cy="4114800"/>
           </a:xfrm>
           <a:prstGeom prst="rect">
             <a:avLst/>
@@ -5369,11 +5651,15 @@
           <a:bodyPr wrap="square" lIns="0" tIns="0" rIns="0" bIns="0" rtlCol="0" anchor="t"/>
           <a:lstStyle/>
           <a:p>
-            <a:pPr indent="0" marL="0">
-              <a:buNone/>
-            </a:pPr>
-            <a:r>
-              <a:rPr lang="en-US" sz="2000" dirty="0">
+            <a:pPr marL="342900" indent="-342900">
+              <a:spcAft>
+                <a:spcPts val="800"/>
+              </a:spcAft>
+              <a:buSzPct val="100000"/>
+              <a:buChar char="•"/>
+            </a:pPr>
+            <a:r>
+              <a:rPr lang="en-US" sz="1400" dirty="0">
                 <a:solidFill>
                   <a:srgbClr val="E6EDF3"/>
                 </a:solidFill>
@@ -5381,16 +5667,20 @@
                 <a:ea typeface="Calibri" pitchFamily="34" charset="-122"/>
                 <a:cs typeface="Calibri" pitchFamily="34" charset="-120"/>
               </a:rPr>
-              <a:t>Reliability is a set of simple rules working together.</a:t>
-            </a:r>
-            <a:endParaRPr lang="en-US" sz="2000" dirty="0"/>
-          </a:p>
-          <a:p>
-            <a:pPr indent="0" marL="0">
-              <a:buNone/>
-            </a:pPr>
-            <a:r>
-              <a:rPr lang="en-US" sz="2000" dirty="0">
+              <a:t>rudp.lua decodes seq, ack, flags, checksum, length</a:t>
+            </a:r>
+            <a:endParaRPr lang="en-US" sz="1400" dirty="0"/>
+          </a:p>
+          <a:p>
+            <a:pPr marL="342900" indent="-342900">
+              <a:spcAft>
+                <a:spcPts val="800"/>
+              </a:spcAft>
+              <a:buSzPct val="100000"/>
+              <a:buChar char="•"/>
+            </a:pPr>
+            <a:r>
+              <a:rPr lang="en-US" sz="1400" dirty="0">
                 <a:solidFill>
                   <a:srgbClr val="E6EDF3"/>
                 </a:solidFill>
@@ -5398,16 +5688,20 @@
                 <a:ea typeface="Calibri" pitchFamily="34" charset="-122"/>
                 <a:cs typeface="Calibri" pitchFamily="34" charset="-120"/>
               </a:rPr>
-              <a:t>Congestion control matters as much as retransmission.</a:t>
-            </a:r>
-            <a:endParaRPr lang="en-US" sz="2000" dirty="0"/>
-          </a:p>
-          <a:p>
-            <a:pPr indent="0" marL="0">
-              <a:buNone/>
-            </a:pPr>
-            <a:r>
-              <a:rPr lang="en-US" sz="2000" dirty="0">
+              <a:t>Filters: smartrudp.flags.data == 1, smartrudp.seq == N</a:t>
+            </a:r>
+            <a:endParaRPr lang="en-US" sz="1400" dirty="0"/>
+          </a:p>
+          <a:p>
+            <a:pPr marL="342900" indent="-342900">
+              <a:spcAft>
+                <a:spcPts val="800"/>
+              </a:spcAft>
+              <a:buSzPct val="100000"/>
+              <a:buChar char="•"/>
+            </a:pPr>
+            <a:r>
+              <a:rPr lang="en-US" sz="1400" dirty="0">
                 <a:solidFill>
                   <a:srgbClr val="E6EDF3"/>
                 </a:solidFill>
@@ -5415,102 +5709,20 @@
                 <a:ea typeface="Calibri" pitchFamily="34" charset="-122"/>
                 <a:cs typeface="Calibri" pitchFamily="34" charset="-120"/>
               </a:rPr>
-              <a:t>Testing tools fail in surprising ways.</a:t>
-            </a:r>
-            <a:endParaRPr lang="en-US" sz="2000" dirty="0"/>
-          </a:p>
-        </p:txBody>
-      </p:sp>
-      <p:sp>
-        <p:nvSpPr>
-          <p:cNvPr id="7" name="Shape 5"/>
-          <p:cNvSpPr/>
-          <p:nvPr/>
-        </p:nvSpPr>
-        <p:spPr>
-          <a:xfrm>
-            <a:off x="6217920" y="1371600"/>
-            <a:ext cx="5394960" cy="4206240"/>
-          </a:xfrm>
-          <a:prstGeom prst="rect">
-            <a:avLst/>
-          </a:prstGeom>
-          <a:solidFill>
-            <a:srgbClr val="141B24"/>
-          </a:solidFill>
-          <a:ln w="12700">
-            <a:solidFill>
-              <a:srgbClr val="FFB000"/>
-            </a:solidFill>
-            <a:prstDash val="solid"/>
-          </a:ln>
-        </p:spPr>
-      </p:sp>
-      <p:sp>
-        <p:nvSpPr>
-          <p:cNvPr id="8" name="Text 6"/>
-          <p:cNvSpPr/>
-          <p:nvPr/>
-        </p:nvSpPr>
-        <p:spPr>
-          <a:xfrm>
-            <a:off x="6400800" y="1508760"/>
-            <a:ext cx="5029200" cy="457200"/>
-          </a:xfrm>
-          <a:prstGeom prst="rect">
-            <a:avLst/>
-          </a:prstGeom>
-          <a:noFill/>
-          <a:ln/>
-        </p:spPr>
-        <p:txBody>
-          <a:bodyPr wrap="square" lIns="0" tIns="0" rIns="0" bIns="0" rtlCol="0" anchor="ctr"/>
-          <a:lstStyle/>
-          <a:p>
-            <a:pPr indent="0" marL="0">
-              <a:buNone/>
-            </a:pPr>
-            <a:r>
-              <a:rPr lang="en-US" sz="2000" b="1" dirty="0">
-                <a:solidFill>
-                  <a:srgbClr val="FFB000"/>
-                </a:solidFill>
-                <a:latin typeface="Courier New" pitchFamily="34" charset="0"/>
-                <a:ea typeface="Courier New" pitchFamily="34" charset="-122"/>
-                <a:cs typeface="Courier New" pitchFamily="34" charset="-120"/>
-              </a:rPr>
-              <a:t>Next</a:t>
-            </a:r>
-            <a:endParaRPr lang="en-US" sz="2000" dirty="0"/>
-          </a:p>
-        </p:txBody>
-      </p:sp>
-      <p:sp>
-        <p:nvSpPr>
-          <p:cNvPr id="9" name="Text 7"/>
-          <p:cNvSpPr/>
-          <p:nvPr/>
-        </p:nvSpPr>
-        <p:spPr>
-          <a:xfrm>
-            <a:off x="6400800" y="2011680"/>
-            <a:ext cx="5029200" cy="3429000"/>
-          </a:xfrm>
-          <a:prstGeom prst="rect">
-            <a:avLst/>
-          </a:prstGeom>
-          <a:noFill/>
-          <a:ln/>
-        </p:spPr>
-        <p:txBody>
-          <a:bodyPr wrap="square" lIns="0" tIns="0" rIns="0" bIns="0" rtlCol="0" anchor="t"/>
-          <a:lstStyle/>
-          <a:p>
-            <a:pPr indent="0" marL="0">
-              <a:buNone/>
-            </a:pPr>
-            <a:r>
-              <a:rPr lang="en-US" sz="2000" dirty="0">
+              <a:t>400 packets, lossy path: 87 (AIMD) and 95 (Smart) repeated data segments seen at the receiver</a:t>
+            </a:r>
+            <a:endParaRPr lang="en-US" sz="1400" dirty="0"/>
+          </a:p>
+          <a:p>
+            <a:pPr marL="342900" indent="-342900">
+              <a:spcAft>
+                <a:spcPts val="800"/>
+              </a:spcAft>
+              <a:buSzPct val="100000"/>
+              <a:buChar char="•"/>
+            </a:pPr>
+            <a:r>
+              <a:rPr lang="en-US" sz="1400" dirty="0">
                 <a:solidFill>
                   <a:srgbClr val="E6EDF3"/>
                 </a:solidFill>
@@ -5518,97 +5730,7 @@
                 <a:ea typeface="Calibri" pitchFamily="34" charset="-122"/>
                 <a:cs typeface="Calibri" pitchFamily="34" charset="-120"/>
               </a:rPr>
-              <a:t>Selective Repeat / SACK</a:t>
-            </a:r>
-            <a:endParaRPr lang="en-US" sz="2000" dirty="0"/>
-          </a:p>
-          <a:p>
-            <a:pPr indent="0" marL="0">
-              <a:buNone/>
-            </a:pPr>
-            <a:r>
-              <a:rPr lang="en-US" sz="2000" dirty="0">
-                <a:solidFill>
-                  <a:srgbClr val="E6EDF3"/>
-                </a:solidFill>
-                <a:latin typeface="Calibri" pitchFamily="34" charset="0"/>
-                <a:ea typeface="Calibri" pitchFamily="34" charset="-122"/>
-                <a:cs typeface="Calibri" pitchFamily="34" charset="-120"/>
-              </a:rPr>
-              <a:t>A stronger learning agent</a:t>
-            </a:r>
-            <a:endParaRPr lang="en-US" sz="2000" dirty="0"/>
-          </a:p>
-          <a:p>
-            <a:pPr indent="0" marL="0">
-              <a:buNone/>
-            </a:pPr>
-            <a:r>
-              <a:rPr lang="en-US" sz="2000" dirty="0">
-                <a:solidFill>
-                  <a:srgbClr val="E6EDF3"/>
-                </a:solidFill>
-                <a:latin typeface="Calibri" pitchFamily="34" charset="0"/>
-                <a:ea typeface="Calibri" pitchFamily="34" charset="-122"/>
-                <a:cs typeface="Calibri" pitchFamily="34" charset="-120"/>
-              </a:rPr>
-              <a:t>Kernel netem and real multi-machine tests</a:t>
-            </a:r>
-            <a:endParaRPr lang="en-US" sz="2000" dirty="0"/>
-          </a:p>
-          <a:p>
-            <a:pPr indent="0" marL="0">
-              <a:buNone/>
-            </a:pPr>
-            <a:r>
-              <a:rPr lang="en-US" sz="2000" dirty="0">
-                <a:solidFill>
-                  <a:srgbClr val="E6EDF3"/>
-                </a:solidFill>
-                <a:latin typeface="Calibri" pitchFamily="34" charset="0"/>
-                <a:ea typeface="Calibri" pitchFamily="34" charset="-122"/>
-                <a:cs typeface="Calibri" pitchFamily="34" charset="-120"/>
-              </a:rPr>
-              <a:t>Run RUDP across a real multi-machine network</a:t>
-            </a:r>
-            <a:endParaRPr lang="en-US" sz="2000" dirty="0"/>
-          </a:p>
-        </p:txBody>
-      </p:sp>
-      <p:sp>
-        <p:nvSpPr>
-          <p:cNvPr id="10" name="Text 8"/>
-          <p:cNvSpPr/>
-          <p:nvPr/>
-        </p:nvSpPr>
-        <p:spPr>
-          <a:xfrm>
-            <a:off x="548640" y="5852160"/>
-            <a:ext cx="10972800" cy="365760"/>
-          </a:xfrm>
-          <a:prstGeom prst="rect">
-            <a:avLst/>
-          </a:prstGeom>
-          <a:noFill/>
-          <a:ln/>
-        </p:spPr>
-        <p:txBody>
-          <a:bodyPr wrap="square" lIns="0" tIns="0" rIns="0" bIns="0" rtlCol="0" anchor="ctr"/>
-          <a:lstStyle/>
-          <a:p>
-            <a:pPr indent="0" marL="0">
-              <a:buNone/>
-            </a:pPr>
-            <a:r>
-              <a:rPr lang="en-US" sz="1400" dirty="0">
-                <a:solidFill>
-                  <a:srgbClr val="8B98A5"/>
-                </a:solidFill>
-                <a:latin typeface="Calibri" pitchFamily="34" charset="0"/>
-                <a:ea typeface="Calibri" pitchFamily="34" charset="-122"/>
-                <a:cs typeface="Calibri" pitchFamily="34" charset="-120"/>
-              </a:rPr>
-              <a:t>Limits: Go-Back-N wastes bandwidth; emulated (not kernel) paths; Smart-RUDP did not beat AIMD.</a:t>
+              <a:t>Trace exported by the program, topology addresses, handshake not included</a:t>
             </a:r>
             <a:endParaRPr lang="en-US" sz="1400" dirty="0"/>
           </a:p>
@@ -5654,8 +5776,8 @@
         </p:nvSpPr>
         <p:spPr>
           <a:xfrm>
-            <a:off x="731520" y="2103120"/>
-            <a:ext cx="10058400" cy="1097280"/>
+            <a:off x="548640" y="320040"/>
+            <a:ext cx="11064240" cy="731520"/>
           </a:xfrm>
           <a:prstGeom prst="rect">
             <a:avLst/>
@@ -5671,7 +5793,7 @@
               <a:buNone/>
             </a:pPr>
             <a:r>
-              <a:rPr lang="en-US" sz="6400" b="1" dirty="0">
+              <a:rPr lang="en-US" sz="3000" b="1" dirty="0">
                 <a:solidFill>
                   <a:srgbClr val="39FF88"/>
                 </a:solidFill>
@@ -5679,9 +5801,9 @@
                 <a:ea typeface="Courier New" pitchFamily="34" charset="-122"/>
                 <a:cs typeface="Courier New" pitchFamily="34" charset="-120"/>
               </a:rPr>
-              <a:t>Thank you</a:t>
-            </a:r>
-            <a:endParaRPr lang="en-US" sz="6400" dirty="0"/>
+              <a:t>Wireshark: real capture</a:t>
+            </a:r>
+            <a:endParaRPr lang="en-US" sz="3000" dirty="0"/>
           </a:p>
         </p:txBody>
       </p:sp>
@@ -5693,8 +5815,8 @@
         </p:nvSpPr>
         <p:spPr>
           <a:xfrm>
-            <a:off x="731520" y="3474720"/>
-            <a:ext cx="10058400" cy="548640"/>
+            <a:off x="9418320" y="6446520"/>
+            <a:ext cx="2377440" cy="274320"/>
           </a:xfrm>
           <a:prstGeom prst="rect">
             <a:avLst/>
@@ -5706,60 +5828,133 @@
           <a:bodyPr wrap="square" lIns="0" tIns="0" rIns="0" bIns="0" rtlCol="0" anchor="ctr"/>
           <a:lstStyle/>
           <a:p>
-            <a:pPr indent="0" marL="0">
-              <a:buNone/>
-            </a:pPr>
-            <a:r>
-              <a:rPr lang="en-US" sz="2600" dirty="0">
-                <a:solidFill>
-                  <a:srgbClr val="E6EDF3"/>
+            <a:pPr algn="r" indent="0" marL="0">
+              <a:buNone/>
+            </a:pPr>
+            <a:r>
+              <a:rPr lang="en-US" sz="1000" dirty="0">
+                <a:solidFill>
+                  <a:srgbClr val="8B98A5"/>
                 </a:solidFill>
                 <a:latin typeface="Courier New" pitchFamily="34" charset="0"/>
                 <a:ea typeface="Courier New" pitchFamily="34" charset="-122"/>
                 <a:cs typeface="Courier New" pitchFamily="34" charset="-120"/>
               </a:rPr>
-              <a:t>github.com/Capsturrrr/rudp</a:t>
-            </a:r>
-            <a:endParaRPr lang="en-US" sz="2600" dirty="0"/>
-          </a:p>
-        </p:txBody>
-      </p:sp>
-      <p:sp>
-        <p:nvSpPr>
-          <p:cNvPr id="4" name="Text 2"/>
-          <p:cNvSpPr/>
-          <p:nvPr/>
-        </p:nvSpPr>
-        <p:spPr>
-          <a:xfrm>
-            <a:off x="731520" y="4206240"/>
-            <a:ext cx="10058400" cy="457200"/>
-          </a:xfrm>
-          <a:prstGeom prst="rect">
-            <a:avLst/>
-          </a:prstGeom>
-          <a:noFill/>
-          <a:ln/>
-        </p:spPr>
-        <p:txBody>
-          <a:bodyPr wrap="square" lIns="0" tIns="0" rIns="0" bIns="0" rtlCol="0" anchor="ctr"/>
-          <a:lstStyle/>
-          <a:p>
-            <a:pPr indent="0" marL="0">
-              <a:buNone/>
-            </a:pPr>
-            <a:r>
-              <a:rPr lang="en-US" sz="1800" dirty="0">
-                <a:solidFill>
-                  <a:srgbClr val="8B98A5"/>
+              <a:t>18 / 20   Smart-RUDP</a:t>
+            </a:r>
+            <a:endParaRPr lang="en-US" sz="1000" dirty="0"/>
+          </a:p>
+        </p:txBody>
+      </p:sp>
+      <p:pic>
+        <p:nvPicPr>
+          <p:cNvPr id="4" name="Image 0" descr="ws_handshake.png">    </p:cNvPr>
+          <p:cNvPicPr>
+            <a:picLocks noChangeAspect="1"/>
+          </p:cNvPicPr>
+          <p:nvPr/>
+        </p:nvPicPr>
+        <p:blipFill>
+          <a:blip r:embed="rId1"/>
+          <a:stretch>
+            <a:fillRect/>
+          </a:stretch>
+        </p:blipFill>
+        <p:spPr>
+          <a:xfrm>
+            <a:off x="548640" y="1097280"/>
+            <a:ext cx="3840480" cy="4456406"/>
+          </a:xfrm>
+          <a:prstGeom prst="rect">
+            <a:avLst/>
+          </a:prstGeom>
+        </p:spPr>
+      </p:pic>
+      <p:pic>
+        <p:nvPicPr>
+          <p:cNvPr id="5" name="Image 1" descr="ws_retx.png">    </p:cNvPr>
+          <p:cNvPicPr>
+            <a:picLocks noChangeAspect="1"/>
+          </p:cNvPicPr>
+          <p:nvPr/>
+        </p:nvPicPr>
+        <p:blipFill>
+          <a:blip r:embed="rId2"/>
+          <a:stretch>
+            <a:fillRect/>
+          </a:stretch>
+        </p:blipFill>
+        <p:spPr>
+          <a:xfrm>
+            <a:off x="4663440" y="1097280"/>
+            <a:ext cx="6949440" cy="3431286"/>
+          </a:xfrm>
+          <a:prstGeom prst="rect">
+            <a:avLst/>
+          </a:prstGeom>
+        </p:spPr>
+      </p:pic>
+      <p:sp>
+        <p:nvSpPr>
+          <p:cNvPr id="6" name="Text 2"/>
+          <p:cNvSpPr/>
+          <p:nvPr/>
+        </p:nvSpPr>
+        <p:spPr>
+          <a:xfrm>
+            <a:off x="4663440" y="4663440"/>
+            <a:ext cx="6949440" cy="1645920"/>
+          </a:xfrm>
+          <a:prstGeom prst="rect">
+            <a:avLst/>
+          </a:prstGeom>
+          <a:noFill/>
+          <a:ln/>
+        </p:spPr>
+        <p:txBody>
+          <a:bodyPr wrap="square" lIns="0" tIns="0" rIns="0" bIns="0" rtlCol="0" anchor="t"/>
+          <a:lstStyle/>
+          <a:p>
+            <a:pPr marL="342900" indent="-342900">
+              <a:spcAft>
+                <a:spcPts val="800"/>
+              </a:spcAft>
+              <a:buSzPct val="100000"/>
+              <a:buChar char="•"/>
+            </a:pPr>
+            <a:r>
+              <a:rPr lang="en-US" sz="1500" dirty="0">
+                <a:solidFill>
+                  <a:srgbClr val="E6EDF3"/>
                 </a:solidFill>
                 <a:latin typeface="Calibri" pitchFamily="34" charset="0"/>
                 <a:ea typeface="Calibri" pitchFamily="34" charset="-122"/>
                 <a:cs typeface="Calibri" pitchFamily="34" charset="-120"/>
               </a:rPr>
-              <a:t>Harshavardhan Mallela   Rohit Arya   Shloak Sinha</a:t>
-            </a:r>
-            <a:endParaRPr lang="en-US" sz="1800" dirty="0"/>
+              <a:t>Left: SYN, SYN-ACK, ACK decoded by the smartrudp dissector (filter frame.number &lt;= 3)</a:t>
+            </a:r>
+            <a:endParaRPr lang="en-US" sz="1500" dirty="0"/>
+          </a:p>
+          <a:p>
+            <a:pPr marL="342900" indent="-342900">
+              <a:spcAft>
+                <a:spcPts val="800"/>
+              </a:spcAft>
+              <a:buSzPct val="100000"/>
+              <a:buChar char="•"/>
+            </a:pPr>
+            <a:r>
+              <a:rPr lang="en-US" sz="1500" dirty="0">
+                <a:solidFill>
+                  <a:srgbClr val="E6EDF3"/>
+                </a:solidFill>
+                <a:latin typeface="Calibri" pitchFamily="34" charset="0"/>
+                <a:ea typeface="Calibri" pitchFamily="34" charset="-122"/>
+                <a:cs typeface="Calibri" pitchFamily="34" charset="-120"/>
+              </a:rPr>
+              <a:t>Right: smartrudp.seq == N shows the same segment sent twice, a retransmission</a:t>
+            </a:r>
+            <a:endParaRPr lang="en-US" sz="1500" dirty="0"/>
           </a:p>
         </p:txBody>
       </p:sp>
@@ -5828,7 +6023,7 @@
                 <a:ea typeface="Courier New" pitchFamily="34" charset="-122"/>
                 <a:cs typeface="Courier New" pitchFamily="34" charset="-120"/>
               </a:rPr>
-              <a:t>Appendix: slow start and congestion avoidance</a:t>
+              <a:t>Learnings and future work</a:t>
             </a:r>
             <a:endParaRPr lang="en-US" sz="3000" dirty="0"/>
           </a:p>
@@ -5867,46 +6062,86 @@
                 <a:ea typeface="Courier New" pitchFamily="34" charset="-122"/>
                 <a:cs typeface="Courier New" pitchFamily="34" charset="-120"/>
               </a:rPr>
-              <a:t>Appendix   Smart-RUDP</a:t>
+              <a:t>19 / 20   Smart-RUDP</a:t>
             </a:r>
             <a:endParaRPr lang="en-US" sz="1000" dirty="0"/>
           </a:p>
         </p:txBody>
       </p:sp>
-      <p:pic>
-        <p:nvPicPr>
-          <p:cNvPr id="4" name="Image 0" descr="fig1_cwnd_no_loss.png">    </p:cNvPr>
-          <p:cNvPicPr>
-            <a:picLocks noChangeAspect="1"/>
-          </p:cNvPicPr>
-          <p:nvPr/>
-        </p:nvPicPr>
-        <p:blipFill>
-          <a:blip r:embed="rId1"/>
-          <a:stretch>
-            <a:fillRect/>
-          </a:stretch>
-        </p:blipFill>
-        <p:spPr>
-          <a:xfrm>
-            <a:off x="731520" y="1188720"/>
-            <a:ext cx="7498080" cy="3998976"/>
-          </a:xfrm>
-          <a:prstGeom prst="rect">
-            <a:avLst/>
-          </a:prstGeom>
-        </p:spPr>
-      </p:pic>
-      <p:sp>
-        <p:nvSpPr>
-          <p:cNvPr id="5" name="Text 2"/>
-          <p:cNvSpPr/>
-          <p:nvPr/>
-        </p:nvSpPr>
-        <p:spPr>
-          <a:xfrm>
-            <a:off x="8503920" y="1463040"/>
-            <a:ext cx="3200400" cy="3200400"/>
+      <p:sp>
+        <p:nvSpPr>
+          <p:cNvPr id="4" name="Shape 2"/>
+          <p:cNvSpPr/>
+          <p:nvPr/>
+        </p:nvSpPr>
+        <p:spPr>
+          <a:xfrm>
+            <a:off x="548640" y="1371600"/>
+            <a:ext cx="5394960" cy="4206240"/>
+          </a:xfrm>
+          <a:prstGeom prst="rect">
+            <a:avLst/>
+          </a:prstGeom>
+          <a:solidFill>
+            <a:srgbClr val="141B24"/>
+          </a:solidFill>
+          <a:ln w="12700">
+            <a:solidFill>
+              <a:srgbClr val="39FF88"/>
+            </a:solidFill>
+            <a:prstDash val="solid"/>
+          </a:ln>
+        </p:spPr>
+      </p:sp>
+      <p:sp>
+        <p:nvSpPr>
+          <p:cNvPr id="5" name="Text 3"/>
+          <p:cNvSpPr/>
+          <p:nvPr/>
+        </p:nvSpPr>
+        <p:spPr>
+          <a:xfrm>
+            <a:off x="731520" y="1508760"/>
+            <a:ext cx="5029200" cy="457200"/>
+          </a:xfrm>
+          <a:prstGeom prst="rect">
+            <a:avLst/>
+          </a:prstGeom>
+          <a:noFill/>
+          <a:ln/>
+        </p:spPr>
+        <p:txBody>
+          <a:bodyPr wrap="square" lIns="0" tIns="0" rIns="0" bIns="0" rtlCol="0" anchor="ctr"/>
+          <a:lstStyle/>
+          <a:p>
+            <a:pPr indent="0" marL="0">
+              <a:buNone/>
+            </a:pPr>
+            <a:r>
+              <a:rPr lang="en-US" sz="2000" b="1" dirty="0">
+                <a:solidFill>
+                  <a:srgbClr val="39FF88"/>
+                </a:solidFill>
+                <a:latin typeface="Courier New" pitchFamily="34" charset="0"/>
+                <a:ea typeface="Courier New" pitchFamily="34" charset="-122"/>
+                <a:cs typeface="Courier New" pitchFamily="34" charset="-120"/>
+              </a:rPr>
+              <a:t>Learned</a:t>
+            </a:r>
+            <a:endParaRPr lang="en-US" sz="2000" dirty="0"/>
+          </a:p>
+        </p:txBody>
+      </p:sp>
+      <p:sp>
+        <p:nvSpPr>
+          <p:cNvPr id="6" name="Text 4"/>
+          <p:cNvSpPr/>
+          <p:nvPr/>
+        </p:nvSpPr>
+        <p:spPr>
+          <a:xfrm>
+            <a:off x="731520" y="2011680"/>
+            <a:ext cx="5029200" cy="3429000"/>
           </a:xfrm>
           <a:prstGeom prst="rect">
             <a:avLst/>
@@ -5918,15 +6153,11 @@
           <a:bodyPr wrap="square" lIns="0" tIns="0" rIns="0" bIns="0" rtlCol="0" anchor="t"/>
           <a:lstStyle/>
           <a:p>
-            <a:pPr marL="342900" indent="-342900">
-              <a:spcAft>
-                <a:spcPts val="800"/>
-              </a:spcAft>
-              <a:buSzPct val="100000"/>
-              <a:buChar char="•"/>
-            </a:pPr>
-            <a:r>
-              <a:rPr lang="en-US" sz="1700" dirty="0">
+            <a:pPr indent="0" marL="0">
+              <a:buNone/>
+            </a:pPr>
+            <a:r>
+              <a:rPr lang="en-US" sz="2000" dirty="0">
                 <a:solidFill>
                   <a:srgbClr val="E6EDF3"/>
                 </a:solidFill>
@@ -5934,20 +6165,16 @@
                 <a:ea typeface="Calibri" pitchFamily="34" charset="-122"/>
                 <a:cs typeface="Calibri" pitchFamily="34" charset="-120"/>
               </a:rPr>
-              <a:t>cwnd starts at 1</a:t>
-            </a:r>
-            <a:endParaRPr lang="en-US" sz="1700" dirty="0"/>
-          </a:p>
-          <a:p>
-            <a:pPr marL="342900" indent="-342900">
-              <a:spcAft>
-                <a:spcPts val="800"/>
-              </a:spcAft>
-              <a:buSzPct val="100000"/>
-              <a:buChar char="•"/>
-            </a:pPr>
-            <a:r>
-              <a:rPr lang="en-US" sz="1700" dirty="0">
+              <a:t>Reliability is a set of simple rules working together.</a:t>
+            </a:r>
+            <a:endParaRPr lang="en-US" sz="2000" dirty="0"/>
+          </a:p>
+          <a:p>
+            <a:pPr indent="0" marL="0">
+              <a:buNone/>
+            </a:pPr>
+            <a:r>
+              <a:rPr lang="en-US" sz="2000" dirty="0">
                 <a:solidFill>
                   <a:srgbClr val="E6EDF3"/>
                 </a:solidFill>
@@ -5955,20 +6182,16 @@
                 <a:ea typeface="Calibri" pitchFamily="34" charset="-122"/>
                 <a:cs typeface="Calibri" pitchFamily="34" charset="-120"/>
               </a:rPr>
-              <a:t>+1 per ACK until ssthresh = 16</a:t>
-            </a:r>
-            <a:endParaRPr lang="en-US" sz="1700" dirty="0"/>
-          </a:p>
-          <a:p>
-            <a:pPr marL="342900" indent="-342900">
-              <a:spcAft>
-                <a:spcPts val="800"/>
-              </a:spcAft>
-              <a:buSzPct val="100000"/>
-              <a:buChar char="•"/>
-            </a:pPr>
-            <a:r>
-              <a:rPr lang="en-US" sz="1700" dirty="0">
+              <a:t>Congestion control matters as much as retransmission.</a:t>
+            </a:r>
+            <a:endParaRPr lang="en-US" sz="2000" dirty="0"/>
+          </a:p>
+          <a:p>
+            <a:pPr indent="0" marL="0">
+              <a:buNone/>
+            </a:pPr>
+            <a:r>
+              <a:rPr lang="en-US" sz="2000" dirty="0">
                 <a:solidFill>
                   <a:srgbClr val="E6EDF3"/>
                 </a:solidFill>
@@ -5976,20 +6199,102 @@
                 <a:ea typeface="Calibri" pitchFamily="34" charset="-122"/>
                 <a:cs typeface="Calibri" pitchFamily="34" charset="-120"/>
               </a:rPr>
-              <a:t>Then +1/cwnd per ACK</a:t>
-            </a:r>
-            <a:endParaRPr lang="en-US" sz="1700" dirty="0"/>
-          </a:p>
-          <a:p>
-            <a:pPr marL="342900" indent="-342900">
-              <a:spcAft>
-                <a:spcPts val="800"/>
-              </a:spcAft>
-              <a:buSzPct val="100000"/>
-              <a:buChar char="•"/>
-            </a:pPr>
-            <a:r>
-              <a:rPr lang="en-US" sz="1700" dirty="0">
+              <a:t>Testing tools fail in surprising ways.</a:t>
+            </a:r>
+            <a:endParaRPr lang="en-US" sz="2000" dirty="0"/>
+          </a:p>
+        </p:txBody>
+      </p:sp>
+      <p:sp>
+        <p:nvSpPr>
+          <p:cNvPr id="7" name="Shape 5"/>
+          <p:cNvSpPr/>
+          <p:nvPr/>
+        </p:nvSpPr>
+        <p:spPr>
+          <a:xfrm>
+            <a:off x="6217920" y="1371600"/>
+            <a:ext cx="5394960" cy="4206240"/>
+          </a:xfrm>
+          <a:prstGeom prst="rect">
+            <a:avLst/>
+          </a:prstGeom>
+          <a:solidFill>
+            <a:srgbClr val="141B24"/>
+          </a:solidFill>
+          <a:ln w="12700">
+            <a:solidFill>
+              <a:srgbClr val="FFB000"/>
+            </a:solidFill>
+            <a:prstDash val="solid"/>
+          </a:ln>
+        </p:spPr>
+      </p:sp>
+      <p:sp>
+        <p:nvSpPr>
+          <p:cNvPr id="8" name="Text 6"/>
+          <p:cNvSpPr/>
+          <p:nvPr/>
+        </p:nvSpPr>
+        <p:spPr>
+          <a:xfrm>
+            <a:off x="6400800" y="1508760"/>
+            <a:ext cx="5029200" cy="457200"/>
+          </a:xfrm>
+          <a:prstGeom prst="rect">
+            <a:avLst/>
+          </a:prstGeom>
+          <a:noFill/>
+          <a:ln/>
+        </p:spPr>
+        <p:txBody>
+          <a:bodyPr wrap="square" lIns="0" tIns="0" rIns="0" bIns="0" rtlCol="0" anchor="ctr"/>
+          <a:lstStyle/>
+          <a:p>
+            <a:pPr indent="0" marL="0">
+              <a:buNone/>
+            </a:pPr>
+            <a:r>
+              <a:rPr lang="en-US" sz="2000" b="1" dirty="0">
+                <a:solidFill>
+                  <a:srgbClr val="FFB000"/>
+                </a:solidFill>
+                <a:latin typeface="Courier New" pitchFamily="34" charset="0"/>
+                <a:ea typeface="Courier New" pitchFamily="34" charset="-122"/>
+                <a:cs typeface="Courier New" pitchFamily="34" charset="-120"/>
+              </a:rPr>
+              <a:t>Next</a:t>
+            </a:r>
+            <a:endParaRPr lang="en-US" sz="2000" dirty="0"/>
+          </a:p>
+        </p:txBody>
+      </p:sp>
+      <p:sp>
+        <p:nvSpPr>
+          <p:cNvPr id="9" name="Text 7"/>
+          <p:cNvSpPr/>
+          <p:nvPr/>
+        </p:nvSpPr>
+        <p:spPr>
+          <a:xfrm>
+            <a:off x="6400800" y="2011680"/>
+            <a:ext cx="5029200" cy="3429000"/>
+          </a:xfrm>
+          <a:prstGeom prst="rect">
+            <a:avLst/>
+          </a:prstGeom>
+          <a:noFill/>
+          <a:ln/>
+        </p:spPr>
+        <p:txBody>
+          <a:bodyPr wrap="square" lIns="0" tIns="0" rIns="0" bIns="0" rtlCol="0" anchor="t"/>
+          <a:lstStyle/>
+          <a:p>
+            <a:pPr indent="0" marL="0">
+              <a:buNone/>
+            </a:pPr>
+            <a:r>
+              <a:rPr lang="en-US" sz="2000" dirty="0">
                 <a:solidFill>
                   <a:srgbClr val="E6EDF3"/>
                 </a:solidFill>
@@ -5997,9 +6302,99 @@
                 <a:ea typeface="Calibri" pitchFamily="34" charset="-122"/>
                 <a:cs typeface="Calibri" pitchFamily="34" charset="-120"/>
               </a:rPr>
-              <a:t>62 packets, final cwnd 18.71</a:t>
-            </a:r>
-            <a:endParaRPr lang="en-US" sz="1700" dirty="0"/>
+              <a:t>Selective Repeat / SACK</a:t>
+            </a:r>
+            <a:endParaRPr lang="en-US" sz="2000" dirty="0"/>
+          </a:p>
+          <a:p>
+            <a:pPr indent="0" marL="0">
+              <a:buNone/>
+            </a:pPr>
+            <a:r>
+              <a:rPr lang="en-US" sz="2000" dirty="0">
+                <a:solidFill>
+                  <a:srgbClr val="E6EDF3"/>
+                </a:solidFill>
+                <a:latin typeface="Calibri" pitchFamily="34" charset="0"/>
+                <a:ea typeface="Calibri" pitchFamily="34" charset="-122"/>
+                <a:cs typeface="Calibri" pitchFamily="34" charset="-120"/>
+              </a:rPr>
+              <a:t>A stronger learning agent</a:t>
+            </a:r>
+            <a:endParaRPr lang="en-US" sz="2000" dirty="0"/>
+          </a:p>
+          <a:p>
+            <a:pPr indent="0" marL="0">
+              <a:buNone/>
+            </a:pPr>
+            <a:r>
+              <a:rPr lang="en-US" sz="2000" dirty="0">
+                <a:solidFill>
+                  <a:srgbClr val="E6EDF3"/>
+                </a:solidFill>
+                <a:latin typeface="Calibri" pitchFamily="34" charset="0"/>
+                <a:ea typeface="Calibri" pitchFamily="34" charset="-122"/>
+                <a:cs typeface="Calibri" pitchFamily="34" charset="-120"/>
+              </a:rPr>
+              <a:t>Kernel netem and real multi-machine tests</a:t>
+            </a:r>
+            <a:endParaRPr lang="en-US" sz="2000" dirty="0"/>
+          </a:p>
+          <a:p>
+            <a:pPr indent="0" marL="0">
+              <a:buNone/>
+            </a:pPr>
+            <a:r>
+              <a:rPr lang="en-US" sz="2000" dirty="0">
+                <a:solidFill>
+                  <a:srgbClr val="E6EDF3"/>
+                </a:solidFill>
+                <a:latin typeface="Calibri" pitchFamily="34" charset="0"/>
+                <a:ea typeface="Calibri" pitchFamily="34" charset="-122"/>
+                <a:cs typeface="Calibri" pitchFamily="34" charset="-120"/>
+              </a:rPr>
+              <a:t>Run RUDP across a real multi-machine network</a:t>
+            </a:r>
+            <a:endParaRPr lang="en-US" sz="2000" dirty="0"/>
+          </a:p>
+        </p:txBody>
+      </p:sp>
+      <p:sp>
+        <p:nvSpPr>
+          <p:cNvPr id="10" name="Text 8"/>
+          <p:cNvSpPr/>
+          <p:nvPr/>
+        </p:nvSpPr>
+        <p:spPr>
+          <a:xfrm>
+            <a:off x="548640" y="5852160"/>
+            <a:ext cx="10972800" cy="365760"/>
+          </a:xfrm>
+          <a:prstGeom prst="rect">
+            <a:avLst/>
+          </a:prstGeom>
+          <a:noFill/>
+          <a:ln/>
+        </p:spPr>
+        <p:txBody>
+          <a:bodyPr wrap="square" lIns="0" tIns="0" rIns="0" bIns="0" rtlCol="0" anchor="ctr"/>
+          <a:lstStyle/>
+          <a:p>
+            <a:pPr indent="0" marL="0">
+              <a:buNone/>
+            </a:pPr>
+            <a:r>
+              <a:rPr lang="en-US" sz="1400" dirty="0">
+                <a:solidFill>
+                  <a:srgbClr val="8B98A5"/>
+                </a:solidFill>
+                <a:latin typeface="Calibri" pitchFamily="34" charset="0"/>
+                <a:ea typeface="Calibri" pitchFamily="34" charset="-122"/>
+                <a:cs typeface="Calibri" pitchFamily="34" charset="-120"/>
+              </a:rPr>
+              <a:t>Limits: Go-Back-N wastes bandwidth; emulated (not kernel) paths; Smart-RUDP did not beat AIMD.</a:t>
+            </a:r>
+            <a:endParaRPr lang="en-US" sz="1400" dirty="0"/>
           </a:p>
         </p:txBody>
       </p:sp>
@@ -6107,7 +6502,7 @@
                 <a:ea typeface="Courier New" pitchFamily="34" charset="-122"/>
                 <a:cs typeface="Courier New" pitchFamily="34" charset="-120"/>
               </a:rPr>
-              <a:t>2 / 18   Smart-RUDP</a:t>
+              <a:t>2 / 20   Smart-RUDP</a:t>
             </a:r>
             <a:endParaRPr lang="en-US" sz="1000" dirty="0"/>
           </a:p>
@@ -6394,6 +6789,395 @@
               <a:t>Our question: can we rebuild TCP's core ideas ourselves, on top of UDP?</a:t>
             </a:r>
             <a:endParaRPr lang="en-US" sz="1800" dirty="0"/>
+          </a:p>
+        </p:txBody>
+      </p:sp>
+    </p:spTree>
+  </p:cSld>
+  <p:clrMapOvr>
+    <a:masterClrMapping/>
+  </p:clrMapOvr>
+</p:sld>
+</file>
+
+<file path=ppt/slides/slide20.xml><?xml version="1.0" encoding="utf-8"?>
+<p:sld xmlns:a="http://schemas.openxmlformats.org/drawingml/2006/main" xmlns:r="http://schemas.openxmlformats.org/officeDocument/2006/relationships" xmlns:p="http://schemas.openxmlformats.org/presentationml/2006/main">
+  <p:cSld name="Slide 20">
+    <p:bg>
+      <p:bgPr>
+        <a:solidFill>
+          <a:srgbClr val="0B0F14"/>
+        </a:solidFill>
+      </p:bgPr>
+    </p:bg>
+    <p:spTree>
+      <p:nvGrpSpPr>
+        <p:cNvPr id="1" name=""/>
+        <p:cNvGrpSpPr/>
+        <p:nvPr/>
+      </p:nvGrpSpPr>
+      <p:grpSpPr>
+        <a:xfrm>
+          <a:off x="0" y="0"/>
+          <a:ext cx="0" cy="0"/>
+          <a:chOff x="0" y="0"/>
+          <a:chExt cx="0" cy="0"/>
+        </a:xfrm>
+      </p:grpSpPr>
+      <p:sp>
+        <p:nvSpPr>
+          <p:cNvPr id="2" name="Text 0"/>
+          <p:cNvSpPr/>
+          <p:nvPr/>
+        </p:nvSpPr>
+        <p:spPr>
+          <a:xfrm>
+            <a:off x="731520" y="2103120"/>
+            <a:ext cx="10058400" cy="1097280"/>
+          </a:xfrm>
+          <a:prstGeom prst="rect">
+            <a:avLst/>
+          </a:prstGeom>
+          <a:noFill/>
+          <a:ln/>
+        </p:spPr>
+        <p:txBody>
+          <a:bodyPr wrap="square" lIns="0" tIns="0" rIns="0" bIns="0" rtlCol="0" anchor="ctr"/>
+          <a:lstStyle/>
+          <a:p>
+            <a:pPr indent="0" marL="0">
+              <a:buNone/>
+            </a:pPr>
+            <a:r>
+              <a:rPr lang="en-US" sz="6400" b="1" dirty="0">
+                <a:solidFill>
+                  <a:srgbClr val="39FF88"/>
+                </a:solidFill>
+                <a:latin typeface="Courier New" pitchFamily="34" charset="0"/>
+                <a:ea typeface="Courier New" pitchFamily="34" charset="-122"/>
+                <a:cs typeface="Courier New" pitchFamily="34" charset="-120"/>
+              </a:rPr>
+              <a:t>Thank you</a:t>
+            </a:r>
+            <a:endParaRPr lang="en-US" sz="6400" dirty="0"/>
+          </a:p>
+        </p:txBody>
+      </p:sp>
+      <p:sp>
+        <p:nvSpPr>
+          <p:cNvPr id="3" name="Text 1"/>
+          <p:cNvSpPr/>
+          <p:nvPr/>
+        </p:nvSpPr>
+        <p:spPr>
+          <a:xfrm>
+            <a:off x="731520" y="3474720"/>
+            <a:ext cx="10058400" cy="548640"/>
+          </a:xfrm>
+          <a:prstGeom prst="rect">
+            <a:avLst/>
+          </a:prstGeom>
+          <a:noFill/>
+          <a:ln/>
+        </p:spPr>
+        <p:txBody>
+          <a:bodyPr wrap="square" lIns="0" tIns="0" rIns="0" bIns="0" rtlCol="0" anchor="ctr"/>
+          <a:lstStyle/>
+          <a:p>
+            <a:pPr indent="0" marL="0">
+              <a:buNone/>
+            </a:pPr>
+            <a:r>
+              <a:rPr lang="en-US" sz="2600" dirty="0">
+                <a:solidFill>
+                  <a:srgbClr val="E6EDF3"/>
+                </a:solidFill>
+                <a:latin typeface="Courier New" pitchFamily="34" charset="0"/>
+                <a:ea typeface="Courier New" pitchFamily="34" charset="-122"/>
+                <a:cs typeface="Courier New" pitchFamily="34" charset="-120"/>
+              </a:rPr>
+              <a:t>github.com/Capsturrrr/rudp</a:t>
+            </a:r>
+            <a:endParaRPr lang="en-US" sz="2600" dirty="0"/>
+          </a:p>
+        </p:txBody>
+      </p:sp>
+      <p:sp>
+        <p:nvSpPr>
+          <p:cNvPr id="4" name="Text 2"/>
+          <p:cNvSpPr/>
+          <p:nvPr/>
+        </p:nvSpPr>
+        <p:spPr>
+          <a:xfrm>
+            <a:off x="731520" y="4206240"/>
+            <a:ext cx="10058400" cy="457200"/>
+          </a:xfrm>
+          <a:prstGeom prst="rect">
+            <a:avLst/>
+          </a:prstGeom>
+          <a:noFill/>
+          <a:ln/>
+        </p:spPr>
+        <p:txBody>
+          <a:bodyPr wrap="square" lIns="0" tIns="0" rIns="0" bIns="0" rtlCol="0" anchor="ctr"/>
+          <a:lstStyle/>
+          <a:p>
+            <a:pPr indent="0" marL="0">
+              <a:buNone/>
+            </a:pPr>
+            <a:r>
+              <a:rPr lang="en-US" sz="1800" dirty="0">
+                <a:solidFill>
+                  <a:srgbClr val="8B98A5"/>
+                </a:solidFill>
+                <a:latin typeface="Calibri" pitchFamily="34" charset="0"/>
+                <a:ea typeface="Calibri" pitchFamily="34" charset="-122"/>
+                <a:cs typeface="Calibri" pitchFamily="34" charset="-120"/>
+              </a:rPr>
+              <a:t>Harshavardhan Mallela   Rohit Arya   Shloak Sinha</a:t>
+            </a:r>
+            <a:endParaRPr lang="en-US" sz="1800" dirty="0"/>
+          </a:p>
+        </p:txBody>
+      </p:sp>
+    </p:spTree>
+  </p:cSld>
+  <p:clrMapOvr>
+    <a:masterClrMapping/>
+  </p:clrMapOvr>
+</p:sld>
+</file>
+
+<file path=ppt/slides/slide21.xml><?xml version="1.0" encoding="utf-8"?>
+<p:sld xmlns:a="http://schemas.openxmlformats.org/drawingml/2006/main" xmlns:r="http://schemas.openxmlformats.org/officeDocument/2006/relationships" xmlns:p="http://schemas.openxmlformats.org/presentationml/2006/main">
+  <p:cSld name="Slide 21">
+    <p:bg>
+      <p:bgPr>
+        <a:solidFill>
+          <a:srgbClr val="0B0F14"/>
+        </a:solidFill>
+      </p:bgPr>
+    </p:bg>
+    <p:spTree>
+      <p:nvGrpSpPr>
+        <p:cNvPr id="1" name=""/>
+        <p:cNvGrpSpPr/>
+        <p:nvPr/>
+      </p:nvGrpSpPr>
+      <p:grpSpPr>
+        <a:xfrm>
+          <a:off x="0" y="0"/>
+          <a:ext cx="0" cy="0"/>
+          <a:chOff x="0" y="0"/>
+          <a:chExt cx="0" cy="0"/>
+        </a:xfrm>
+      </p:grpSpPr>
+      <p:sp>
+        <p:nvSpPr>
+          <p:cNvPr id="2" name="Text 0"/>
+          <p:cNvSpPr/>
+          <p:nvPr/>
+        </p:nvSpPr>
+        <p:spPr>
+          <a:xfrm>
+            <a:off x="548640" y="320040"/>
+            <a:ext cx="11064240" cy="731520"/>
+          </a:xfrm>
+          <a:prstGeom prst="rect">
+            <a:avLst/>
+          </a:prstGeom>
+          <a:noFill/>
+          <a:ln/>
+        </p:spPr>
+        <p:txBody>
+          <a:bodyPr wrap="square" lIns="0" tIns="0" rIns="0" bIns="0" rtlCol="0" anchor="ctr"/>
+          <a:lstStyle/>
+          <a:p>
+            <a:pPr indent="0" marL="0">
+              <a:buNone/>
+            </a:pPr>
+            <a:r>
+              <a:rPr lang="en-US" sz="3000" b="1" dirty="0">
+                <a:solidFill>
+                  <a:srgbClr val="39FF88"/>
+                </a:solidFill>
+                <a:latin typeface="Courier New" pitchFamily="34" charset="0"/>
+                <a:ea typeface="Courier New" pitchFamily="34" charset="-122"/>
+                <a:cs typeface="Courier New" pitchFamily="34" charset="-120"/>
+              </a:rPr>
+              <a:t>Appendix: slow start and congestion avoidance</a:t>
+            </a:r>
+            <a:endParaRPr lang="en-US" sz="3000" dirty="0"/>
+          </a:p>
+        </p:txBody>
+      </p:sp>
+      <p:sp>
+        <p:nvSpPr>
+          <p:cNvPr id="3" name="Text 1"/>
+          <p:cNvSpPr/>
+          <p:nvPr/>
+        </p:nvSpPr>
+        <p:spPr>
+          <a:xfrm>
+            <a:off x="9418320" y="6446520"/>
+            <a:ext cx="2377440" cy="274320"/>
+          </a:xfrm>
+          <a:prstGeom prst="rect">
+            <a:avLst/>
+          </a:prstGeom>
+          <a:noFill/>
+          <a:ln/>
+        </p:spPr>
+        <p:txBody>
+          <a:bodyPr wrap="square" lIns="0" tIns="0" rIns="0" bIns="0" rtlCol="0" anchor="ctr"/>
+          <a:lstStyle/>
+          <a:p>
+            <a:pPr algn="r" indent="0" marL="0">
+              <a:buNone/>
+            </a:pPr>
+            <a:r>
+              <a:rPr lang="en-US" sz="1000" dirty="0">
+                <a:solidFill>
+                  <a:srgbClr val="8B98A5"/>
+                </a:solidFill>
+                <a:latin typeface="Courier New" pitchFamily="34" charset="0"/>
+                <a:ea typeface="Courier New" pitchFamily="34" charset="-122"/>
+                <a:cs typeface="Courier New" pitchFamily="34" charset="-120"/>
+              </a:rPr>
+              <a:t>Appendix   Smart-RUDP</a:t>
+            </a:r>
+            <a:endParaRPr lang="en-US" sz="1000" dirty="0"/>
+          </a:p>
+        </p:txBody>
+      </p:sp>
+      <p:pic>
+        <p:nvPicPr>
+          <p:cNvPr id="4" name="Image 0" descr="fig1_cwnd_no_loss.png">    </p:cNvPr>
+          <p:cNvPicPr>
+            <a:picLocks noChangeAspect="1"/>
+          </p:cNvPicPr>
+          <p:nvPr/>
+        </p:nvPicPr>
+        <p:blipFill>
+          <a:blip r:embed="rId1"/>
+          <a:stretch>
+            <a:fillRect/>
+          </a:stretch>
+        </p:blipFill>
+        <p:spPr>
+          <a:xfrm>
+            <a:off x="731520" y="1188720"/>
+            <a:ext cx="7498080" cy="3998976"/>
+          </a:xfrm>
+          <a:prstGeom prst="rect">
+            <a:avLst/>
+          </a:prstGeom>
+        </p:spPr>
+      </p:pic>
+      <p:sp>
+        <p:nvSpPr>
+          <p:cNvPr id="5" name="Text 2"/>
+          <p:cNvSpPr/>
+          <p:nvPr/>
+        </p:nvSpPr>
+        <p:spPr>
+          <a:xfrm>
+            <a:off x="8503920" y="1463040"/>
+            <a:ext cx="3200400" cy="3200400"/>
+          </a:xfrm>
+          <a:prstGeom prst="rect">
+            <a:avLst/>
+          </a:prstGeom>
+          <a:noFill/>
+          <a:ln/>
+        </p:spPr>
+        <p:txBody>
+          <a:bodyPr wrap="square" lIns="0" tIns="0" rIns="0" bIns="0" rtlCol="0" anchor="t"/>
+          <a:lstStyle/>
+          <a:p>
+            <a:pPr marL="342900" indent="-342900">
+              <a:spcAft>
+                <a:spcPts val="800"/>
+              </a:spcAft>
+              <a:buSzPct val="100000"/>
+              <a:buChar char="•"/>
+            </a:pPr>
+            <a:r>
+              <a:rPr lang="en-US" sz="1700" dirty="0">
+                <a:solidFill>
+                  <a:srgbClr val="E6EDF3"/>
+                </a:solidFill>
+                <a:latin typeface="Calibri" pitchFamily="34" charset="0"/>
+                <a:ea typeface="Calibri" pitchFamily="34" charset="-122"/>
+                <a:cs typeface="Calibri" pitchFamily="34" charset="-120"/>
+              </a:rPr>
+              <a:t>cwnd starts at 1</a:t>
+            </a:r>
+            <a:endParaRPr lang="en-US" sz="1700" dirty="0"/>
+          </a:p>
+          <a:p>
+            <a:pPr marL="342900" indent="-342900">
+              <a:spcAft>
+                <a:spcPts val="800"/>
+              </a:spcAft>
+              <a:buSzPct val="100000"/>
+              <a:buChar char="•"/>
+            </a:pPr>
+            <a:r>
+              <a:rPr lang="en-US" sz="1700" dirty="0">
+                <a:solidFill>
+                  <a:srgbClr val="E6EDF3"/>
+                </a:solidFill>
+                <a:latin typeface="Calibri" pitchFamily="34" charset="0"/>
+                <a:ea typeface="Calibri" pitchFamily="34" charset="-122"/>
+                <a:cs typeface="Calibri" pitchFamily="34" charset="-120"/>
+              </a:rPr>
+              <a:t>+1 per ACK until ssthresh = 16</a:t>
+            </a:r>
+            <a:endParaRPr lang="en-US" sz="1700" dirty="0"/>
+          </a:p>
+          <a:p>
+            <a:pPr marL="342900" indent="-342900">
+              <a:spcAft>
+                <a:spcPts val="800"/>
+              </a:spcAft>
+              <a:buSzPct val="100000"/>
+              <a:buChar char="•"/>
+            </a:pPr>
+            <a:r>
+              <a:rPr lang="en-US" sz="1700" dirty="0">
+                <a:solidFill>
+                  <a:srgbClr val="E6EDF3"/>
+                </a:solidFill>
+                <a:latin typeface="Calibri" pitchFamily="34" charset="0"/>
+                <a:ea typeface="Calibri" pitchFamily="34" charset="-122"/>
+                <a:cs typeface="Calibri" pitchFamily="34" charset="-120"/>
+              </a:rPr>
+              <a:t>Then +1/cwnd per ACK</a:t>
+            </a:r>
+            <a:endParaRPr lang="en-US" sz="1700" dirty="0"/>
+          </a:p>
+          <a:p>
+            <a:pPr marL="342900" indent="-342900">
+              <a:spcAft>
+                <a:spcPts val="800"/>
+              </a:spcAft>
+              <a:buSzPct val="100000"/>
+              <a:buChar char="•"/>
+            </a:pPr>
+            <a:r>
+              <a:rPr lang="en-US" sz="1700" dirty="0">
+                <a:solidFill>
+                  <a:srgbClr val="E6EDF3"/>
+                </a:solidFill>
+                <a:latin typeface="Calibri" pitchFamily="34" charset="0"/>
+                <a:ea typeface="Calibri" pitchFamily="34" charset="-122"/>
+                <a:cs typeface="Calibri" pitchFamily="34" charset="-120"/>
+              </a:rPr>
+              <a:t>62 packets, final cwnd 18.71</a:t>
+            </a:r>
+            <a:endParaRPr lang="en-US" sz="1700" dirty="0"/>
           </a:p>
         </p:txBody>
       </p:sp>
@@ -6501,7 +7285,7 @@
                 <a:ea typeface="Courier New" pitchFamily="34" charset="-122"/>
                 <a:cs typeface="Courier New" pitchFamily="34" charset="-120"/>
               </a:rPr>
-              <a:t>3 / 18   Smart-RUDP</a:t>
+              <a:t>3 / 20   Smart-RUDP</a:t>
             </a:r>
             <a:endParaRPr lang="en-US" sz="1000" dirty="0"/>
           </a:p>
@@ -6895,7 +7679,7 @@
                 <a:ea typeface="Courier New" pitchFamily="34" charset="-122"/>
                 <a:cs typeface="Courier New" pitchFamily="34" charset="-120"/>
               </a:rPr>
-              <a:t>4 / 18   Smart-RUDP</a:t>
+              <a:t>4 / 20   Smart-RUDP</a:t>
             </a:r>
             <a:endParaRPr lang="en-US" sz="1000" dirty="0"/>
           </a:p>
@@ -7456,7 +8240,7 @@
                 <a:ea typeface="Courier New" pitchFamily="34" charset="-122"/>
                 <a:cs typeface="Courier New" pitchFamily="34" charset="-120"/>
               </a:rPr>
-              <a:t>5 / 18   Smart-RUDP</a:t>
+              <a:t>5 / 20   Smart-RUDP</a:t>
             </a:r>
             <a:endParaRPr lang="en-US" sz="1000" dirty="0"/>
           </a:p>
@@ -8895,7 +9679,7 @@
                 <a:ea typeface="Courier New" pitchFamily="34" charset="-122"/>
                 <a:cs typeface="Courier New" pitchFamily="34" charset="-120"/>
               </a:rPr>
-              <a:t>6 / 18   Smart-RUDP</a:t>
+              <a:t>6 / 20   Smart-RUDP</a:t>
             </a:r>
             <a:endParaRPr lang="en-US" sz="1000" dirty="0"/>
           </a:p>
@@ -10130,7 +10914,7 @@
                 <a:ea typeface="Courier New" pitchFamily="34" charset="-122"/>
                 <a:cs typeface="Courier New" pitchFamily="34" charset="-120"/>
               </a:rPr>
-              <a:t>7 / 18   Smart-RUDP</a:t>
+              <a:t>7 / 20   Smart-RUDP</a:t>
             </a:r>
             <a:endParaRPr lang="en-US" sz="1000" dirty="0"/>
           </a:p>
@@ -10573,7 +11357,7 @@
                 <a:ea typeface="Courier New" pitchFamily="34" charset="-122"/>
                 <a:cs typeface="Courier New" pitchFamily="34" charset="-120"/>
               </a:rPr>
-              <a:t>8 / 18   Smart-RUDP</a:t>
+              <a:t>8 / 20   Smart-RUDP</a:t>
             </a:r>
             <a:endParaRPr lang="en-US" sz="1000" dirty="0"/>
           </a:p>
@@ -10873,7 +11657,7 @@
                 <a:ea typeface="Courier New" pitchFamily="34" charset="-122"/>
                 <a:cs typeface="Courier New" pitchFamily="34" charset="-120"/>
               </a:rPr>
-              <a:t>9 / 18   Smart-RUDP</a:t>
+              <a:t>9 / 20   Smart-RUDP</a:t>
             </a:r>
             <a:endParaRPr lang="en-US" sz="1000" dirty="0"/>
           </a:p>

</xml_diff>

<commit_message>
Report and deck: add RUDP Chat section and slide
Co-Authored-By: Claude Sonnet 5.5 <noreply@anthropic.com>
Claude-Session: https://claude.ai/code/session_01NX2zRNpdVAnzFNKmqomzKu
</commit_message>
<xml_diff>
--- a/docs/final/RUDP_Presentation.pptx
+++ b/docs/final/RUDP_Presentation.pptx
@@ -26,9 +26,10 @@
     <p:sldId id="274" r:id="rId20"/>
     <p:sldId id="275" r:id="rId21"/>
     <p:sldId id="276" r:id="rId22"/>
+    <p:sldId id="277" r:id="rId23"/>
   </p:sldIdLst>
   <p:notesMasterIdLst>
-    <p:notesMasterId r:id="rId23"/>
+    <p:notesMasterId r:id="rId24"/>
   </p:notesMasterIdLst>
   <p:sldSz cx="12192000" cy="6858000"/>
   <p:notesSz cx="6858000" cy="12192000"/>
@@ -1690,6 +1691,94 @@
             <a:fld id="{F7021451-1387-4CA6-816F-3879F97B5CBC}" type="slidenum">
               <a:rPr lang="en-US"/>
               <a:t>21</a:t>
+            </a:fld>
+            <a:endParaRPr lang="en-US"/>
+          </a:p>
+        </p:txBody>
+      </p:sp>
+    </p:spTree>
+    <p:extLst>
+      <p:ext uri="{BB962C8B-B14F-4D97-AF65-F5344CB8AC3E}">
+        <p14:creationId xmlns:p14="http://schemas.microsoft.com/office/powerpoint/2010/main" val="1024086991"/>
+      </p:ext>
+    </p:extLst>
+  </p:cSld>
+  <p:clrMapOvr>
+    <a:masterClrMapping/>
+  </p:clrMapOvr>
+</p:notes>
+</file>
+
+<file path=ppt/notesSlides/notesSlide22.xml><?xml version="1.0" encoding="utf-8"?>
+<p:notes xmlns:a="http://schemas.openxmlformats.org/drawingml/2006/main" xmlns:r="http://schemas.openxmlformats.org/officeDocument/2006/relationships" xmlns:p="http://schemas.openxmlformats.org/presentationml/2006/main">
+  <p:cSld>
+    <p:spTree>
+      <p:nvGrpSpPr>
+        <p:cNvPr id="1" name=""/>
+        <p:cNvGrpSpPr/>
+        <p:nvPr/>
+      </p:nvGrpSpPr>
+      <p:grpSpPr>
+        <a:xfrm>
+          <a:off x="0" y="0"/>
+          <a:ext cx="0" cy="0"/>
+          <a:chOff x="0" y="0"/>
+          <a:chExt cx="0" cy="0"/>
+        </a:xfrm>
+      </p:grpSpPr>
+      <p:sp>
+        <p:nvSpPr>
+          <p:cNvPr id="2" name="Slide Image Placeholder 1"/>
+          <p:cNvSpPr>
+            <a:spLocks noGrp="1" noRot="1" noChangeAspect="1"/>
+          </p:cNvSpPr>
+          <p:nvPr>
+            <p:ph type="sldImg"/>
+          </p:nvPr>
+        </p:nvSpPr>
+        <p:spPr/>
+      </p:sp>
+      <p:sp>
+        <p:nvSpPr>
+          <p:cNvPr id="3" name="Notes Placeholder 2"/>
+          <p:cNvSpPr>
+            <a:spLocks noGrp="1"/>
+          </p:cNvSpPr>
+          <p:nvPr>
+            <p:ph type="body" idx="1"/>
+          </p:nvPr>
+        </p:nvSpPr>
+        <p:spPr/>
+        <p:txBody>
+          <a:bodyPr/>
+          <a:lstStyle/>
+          <a:p>
+            <a:r>
+              <a:rPr lang="en-US" dirty="0"/>
+              <a:t/>
+            </a:r>
+            <a:endParaRPr lang="en-US" dirty="0"/>
+          </a:p>
+        </p:txBody>
+      </p:sp>
+      <p:sp>
+        <p:nvSpPr>
+          <p:cNvPr id="4" name="Slide Number Placeholder 3"/>
+          <p:cNvSpPr>
+            <a:spLocks noGrp="1"/>
+          </p:cNvSpPr>
+          <p:nvPr>
+            <p:ph type="sldNum" sz="quarter" idx="10"/>
+          </p:nvPr>
+        </p:nvSpPr>
+        <p:spPr/>
+        <p:txBody>
+          <a:bodyPr/>
+          <a:lstStyle/>
+          <a:p>
+            <a:fld id="{F7021451-1387-4CA6-816F-3879F97B5CBC}" type="slidenum">
+              <a:rPr lang="en-US"/>
+              <a:t>22</a:t>
             </a:fld>
             <a:endParaRPr lang="en-US"/>
           </a:p>
@@ -2915,7 +3004,7 @@
                 <a:ea typeface="Courier New" pitchFamily="34" charset="-122"/>
                 <a:cs typeface="Courier New" pitchFamily="34" charset="-120"/>
               </a:rPr>
-              <a:t>10 / 20   Smart-RUDP</a:t>
+              <a:t>10 / 21   Smart-RUDP</a:t>
             </a:r>
             <a:endParaRPr lang="en-US" sz="1000" dirty="0"/>
           </a:p>
@@ -3112,7 +3201,7 @@
                 <a:ea typeface="Courier New" pitchFamily="34" charset="-122"/>
                 <a:cs typeface="Courier New" pitchFamily="34" charset="-120"/>
               </a:rPr>
-              <a:t>11 / 20   Smart-RUDP</a:t>
+              <a:t>11 / 21   Smart-RUDP</a:t>
             </a:r>
             <a:endParaRPr lang="en-US" sz="1000" dirty="0"/>
           </a:p>
@@ -3942,7 +4031,7 @@
                 <a:ea typeface="Courier New" pitchFamily="34" charset="-122"/>
                 <a:cs typeface="Courier New" pitchFamily="34" charset="-120"/>
               </a:rPr>
-              <a:t>12 / 20   Smart-RUDP</a:t>
+              <a:t>12 / 21   Smart-RUDP</a:t>
             </a:r>
             <a:endParaRPr lang="en-US" sz="1000" dirty="0"/>
           </a:p>
@@ -4218,7 +4307,7 @@
                 <a:ea typeface="Courier New" pitchFamily="34" charset="-122"/>
                 <a:cs typeface="Courier New" pitchFamily="34" charset="-120"/>
               </a:rPr>
-              <a:t>13 / 20   Smart-RUDP</a:t>
+              <a:t>13 / 21   Smart-RUDP</a:t>
             </a:r>
             <a:endParaRPr lang="en-US" sz="1000" dirty="0"/>
           </a:p>
@@ -4518,7 +4607,7 @@
                 <a:ea typeface="Courier New" pitchFamily="34" charset="-122"/>
                 <a:cs typeface="Courier New" pitchFamily="34" charset="-120"/>
               </a:rPr>
-              <a:t>14 / 20   Smart-RUDP</a:t>
+              <a:t>14 / 21   Smart-RUDP</a:t>
             </a:r>
             <a:endParaRPr lang="en-US" sz="1000" dirty="0"/>
           </a:p>
@@ -4902,7 +4991,7 @@
                 <a:ea typeface="Courier New" pitchFamily="34" charset="-122"/>
                 <a:cs typeface="Courier New" pitchFamily="34" charset="-120"/>
               </a:rPr>
-              <a:t>15 / 20   Smart-RUDP</a:t>
+              <a:t>15 / 21   Smart-RUDP</a:t>
             </a:r>
             <a:endParaRPr lang="en-US" sz="1000" dirty="0"/>
           </a:p>
@@ -5360,7 +5449,7 @@
                 <a:ea typeface="Courier New" pitchFamily="34" charset="-122"/>
                 <a:cs typeface="Courier New" pitchFamily="34" charset="-120"/>
               </a:rPr>
-              <a:t>16 / 20   Smart-RUDP</a:t>
+              <a:t>16 / 21   Smart-RUDP</a:t>
             </a:r>
             <a:endParaRPr lang="en-US" sz="1000" dirty="0"/>
           </a:p>
@@ -5600,7 +5689,7 @@
                 <a:ea typeface="Courier New" pitchFamily="34" charset="-122"/>
                 <a:cs typeface="Courier New" pitchFamily="34" charset="-120"/>
               </a:rPr>
-              <a:t>17 / 20   Smart-RUDP</a:t>
+              <a:t>17 / 21   Smart-RUDP</a:t>
             </a:r>
             <a:endParaRPr lang="en-US" sz="1000" dirty="0"/>
           </a:p>
@@ -5840,7 +5929,7 @@
                 <a:ea typeface="Courier New" pitchFamily="34" charset="-122"/>
                 <a:cs typeface="Courier New" pitchFamily="34" charset="-120"/>
               </a:rPr>
-              <a:t>18 / 20   Smart-RUDP</a:t>
+              <a:t>18 / 21   Smart-RUDP</a:t>
             </a:r>
             <a:endParaRPr lang="en-US" sz="1000" dirty="0"/>
           </a:p>
@@ -6023,7 +6112,7 @@
                 <a:ea typeface="Courier New" pitchFamily="34" charset="-122"/>
                 <a:cs typeface="Courier New" pitchFamily="34" charset="-120"/>
               </a:rPr>
-              <a:t>Learnings and future work</a:t>
+              <a:t>Demo: RUDP Chat over the internet</a:t>
             </a:r>
             <a:endParaRPr lang="en-US" sz="3000" dirty="0"/>
           </a:p>
@@ -6062,86 +6151,46 @@
                 <a:ea typeface="Courier New" pitchFamily="34" charset="-122"/>
                 <a:cs typeface="Courier New" pitchFamily="34" charset="-120"/>
               </a:rPr>
-              <a:t>19 / 20   Smart-RUDP</a:t>
+              <a:t>19 / 21   Smart-RUDP</a:t>
             </a:r>
             <a:endParaRPr lang="en-US" sz="1000" dirty="0"/>
           </a:p>
         </p:txBody>
       </p:sp>
-      <p:sp>
-        <p:nvSpPr>
-          <p:cNvPr id="4" name="Shape 2"/>
-          <p:cNvSpPr/>
-          <p:nvPr/>
-        </p:nvSpPr>
-        <p:spPr>
-          <a:xfrm>
-            <a:off x="548640" y="1371600"/>
-            <a:ext cx="5394960" cy="4206240"/>
-          </a:xfrm>
-          <a:prstGeom prst="rect">
-            <a:avLst/>
-          </a:prstGeom>
-          <a:solidFill>
-            <a:srgbClr val="141B24"/>
-          </a:solidFill>
-          <a:ln w="12700">
-            <a:solidFill>
-              <a:srgbClr val="39FF88"/>
-            </a:solidFill>
-            <a:prstDash val="solid"/>
-          </a:ln>
-        </p:spPr>
-      </p:sp>
-      <p:sp>
-        <p:nvSpPr>
-          <p:cNvPr id="5" name="Text 3"/>
-          <p:cNvSpPr/>
-          <p:nvPr/>
-        </p:nvSpPr>
-        <p:spPr>
-          <a:xfrm>
-            <a:off x="731520" y="1508760"/>
-            <a:ext cx="5029200" cy="457200"/>
-          </a:xfrm>
-          <a:prstGeom prst="rect">
-            <a:avLst/>
-          </a:prstGeom>
-          <a:noFill/>
-          <a:ln/>
-        </p:spPr>
-        <p:txBody>
-          <a:bodyPr wrap="square" lIns="0" tIns="0" rIns="0" bIns="0" rtlCol="0" anchor="ctr"/>
-          <a:lstStyle/>
-          <a:p>
-            <a:pPr indent="0" marL="0">
-              <a:buNone/>
-            </a:pPr>
-            <a:r>
-              <a:rPr lang="en-US" sz="2000" b="1" dirty="0">
-                <a:solidFill>
-                  <a:srgbClr val="39FF88"/>
-                </a:solidFill>
-                <a:latin typeface="Courier New" pitchFamily="34" charset="0"/>
-                <a:ea typeface="Courier New" pitchFamily="34" charset="-122"/>
-                <a:cs typeface="Courier New" pitchFamily="34" charset="-120"/>
-              </a:rPr>
-              <a:t>Learned</a:t>
-            </a:r>
-            <a:endParaRPr lang="en-US" sz="2000" dirty="0"/>
-          </a:p>
-        </p:txBody>
-      </p:sp>
-      <p:sp>
-        <p:nvSpPr>
-          <p:cNvPr id="6" name="Text 4"/>
-          <p:cNvSpPr/>
-          <p:nvPr/>
-        </p:nvSpPr>
-        <p:spPr>
-          <a:xfrm>
-            <a:off x="731520" y="2011680"/>
-            <a:ext cx="5029200" cy="3429000"/>
+      <p:pic>
+        <p:nvPicPr>
+          <p:cNvPr id="4" name="Image 0" descr="web_chat.png">    </p:cNvPr>
+          <p:cNvPicPr>
+            <a:picLocks noChangeAspect="1"/>
+          </p:cNvPicPr>
+          <p:nvPr/>
+        </p:nvPicPr>
+        <p:blipFill>
+          <a:blip r:embed="rId1"/>
+          <a:stretch>
+            <a:fillRect/>
+          </a:stretch>
+        </p:blipFill>
+        <p:spPr>
+          <a:xfrm>
+            <a:off x="457200" y="1097280"/>
+            <a:ext cx="7223760" cy="4202915"/>
+          </a:xfrm>
+          <a:prstGeom prst="rect">
+            <a:avLst/>
+          </a:prstGeom>
+        </p:spPr>
+      </p:pic>
+      <p:sp>
+        <p:nvSpPr>
+          <p:cNvPr id="5" name="Text 2"/>
+          <p:cNvSpPr/>
+          <p:nvPr/>
+        </p:nvSpPr>
+        <p:spPr>
+          <a:xfrm>
+            <a:off x="7955280" y="1188720"/>
+            <a:ext cx="3840480" cy="4389120"/>
           </a:xfrm>
           <a:prstGeom prst="rect">
             <a:avLst/>
@@ -6153,11 +6202,15 @@
           <a:bodyPr wrap="square" lIns="0" tIns="0" rIns="0" bIns="0" rtlCol="0" anchor="t"/>
           <a:lstStyle/>
           <a:p>
-            <a:pPr indent="0" marL="0">
-              <a:buNone/>
-            </a:pPr>
-            <a:r>
-              <a:rPr lang="en-US" sz="2000" dirty="0">
+            <a:pPr marL="342900" indent="-342900">
+              <a:spcAft>
+                <a:spcPts val="800"/>
+              </a:spcAft>
+              <a:buSzPct val="100000"/>
+              <a:buChar char="•"/>
+            </a:pPr>
+            <a:r>
+              <a:rPr lang="en-US" sz="1600" dirty="0">
                 <a:solidFill>
                   <a:srgbClr val="E6EDF3"/>
                 </a:solidFill>
@@ -6165,16 +6218,20 @@
                 <a:ea typeface="Calibri" pitchFamily="34" charset="-122"/>
                 <a:cs typeface="Calibri" pitchFamily="34" charset="-120"/>
               </a:rPr>
-              <a:t>Reliability is a set of simple rules working together.</a:t>
-            </a:r>
-            <a:endParaRPr lang="en-US" sz="2000" dirty="0"/>
-          </a:p>
-          <a:p>
-            <a:pPr indent="0" marL="0">
-              <a:buNone/>
-            </a:pPr>
-            <a:r>
-              <a:rPr lang="en-US" sz="2000" dirty="0">
+              <a:t>Each message is one RUDP segment: numbered, checksummed, ACKed in order</a:t>
+            </a:r>
+            <a:endParaRPr lang="en-US" sz="1600" dirty="0"/>
+          </a:p>
+          <a:p>
+            <a:pPr marL="342900" indent="-342900">
+              <a:spcAft>
+                <a:spcPts val="800"/>
+              </a:spcAft>
+              <a:buSzPct val="100000"/>
+              <a:buChar char="•"/>
+            </a:pPr>
+            <a:r>
+              <a:rPr lang="en-US" sz="1600" dirty="0">
                 <a:solidFill>
                   <a:srgbClr val="E6EDF3"/>
                 </a:solidFill>
@@ -6182,16 +6239,20 @@
                 <a:ea typeface="Calibri" pitchFamily="34" charset="-122"/>
                 <a:cs typeface="Calibri" pitchFamily="34" charset="-120"/>
               </a:rPr>
-              <a:t>Congestion control matters as much as retransmission.</a:t>
-            </a:r>
-            <a:endParaRPr lang="en-US" sz="2000" dirty="0"/>
-          </a:p>
-          <a:p>
-            <a:pPr indent="0" marL="0">
-              <a:buNone/>
-            </a:pPr>
-            <a:r>
-              <a:rPr lang="en-US" sz="2000" dirty="0">
+              <a:t>Browser UI via a small gateway; terminal version too</a:t>
+            </a:r>
+            <a:endParaRPr lang="en-US" sz="1600" dirty="0"/>
+          </a:p>
+          <a:p>
+            <a:pPr marL="342900" indent="-342900">
+              <a:spcAft>
+                <a:spcPts val="800"/>
+              </a:spcAft>
+              <a:buSzPct val="100000"/>
+              <a:buChar char="•"/>
+            </a:pPr>
+            <a:r>
+              <a:rPr lang="en-US" sz="1600" dirty="0">
                 <a:solidFill>
                   <a:srgbClr val="E6EDF3"/>
                 </a:solidFill>
@@ -6199,102 +6260,20 @@
                 <a:ea typeface="Calibri" pitchFamily="34" charset="-122"/>
                 <a:cs typeface="Calibri" pitchFamily="34" charset="-120"/>
               </a:rPr>
-              <a:t>Testing tools fail in surprising ways.</a:t>
-            </a:r>
-            <a:endParaRPr lang="en-US" sz="2000" dirty="0"/>
-          </a:p>
-        </p:txBody>
-      </p:sp>
-      <p:sp>
-        <p:nvSpPr>
-          <p:cNvPr id="7" name="Shape 5"/>
-          <p:cNvSpPr/>
-          <p:nvPr/>
-        </p:nvSpPr>
-        <p:spPr>
-          <a:xfrm>
-            <a:off x="6217920" y="1371600"/>
-            <a:ext cx="5394960" cy="4206240"/>
-          </a:xfrm>
-          <a:prstGeom prst="rect">
-            <a:avLst/>
-          </a:prstGeom>
-          <a:solidFill>
-            <a:srgbClr val="141B24"/>
-          </a:solidFill>
-          <a:ln w="12700">
-            <a:solidFill>
-              <a:srgbClr val="FFB000"/>
-            </a:solidFill>
-            <a:prstDash val="solid"/>
-          </a:ln>
-        </p:spPr>
-      </p:sp>
-      <p:sp>
-        <p:nvSpPr>
-          <p:cNvPr id="8" name="Text 6"/>
-          <p:cNvSpPr/>
-          <p:nvPr/>
-        </p:nvSpPr>
-        <p:spPr>
-          <a:xfrm>
-            <a:off x="6400800" y="1508760"/>
-            <a:ext cx="5029200" cy="457200"/>
-          </a:xfrm>
-          <a:prstGeom prst="rect">
-            <a:avLst/>
-          </a:prstGeom>
-          <a:noFill/>
-          <a:ln/>
-        </p:spPr>
-        <p:txBody>
-          <a:bodyPr wrap="square" lIns="0" tIns="0" rIns="0" bIns="0" rtlCol="0" anchor="ctr"/>
-          <a:lstStyle/>
-          <a:p>
-            <a:pPr indent="0" marL="0">
-              <a:buNone/>
-            </a:pPr>
-            <a:r>
-              <a:rPr lang="en-US" sz="2000" b="1" dirty="0">
-                <a:solidFill>
-                  <a:srgbClr val="FFB000"/>
-                </a:solidFill>
-                <a:latin typeface="Courier New" pitchFamily="34" charset="0"/>
-                <a:ea typeface="Courier New" pitchFamily="34" charset="-122"/>
-                <a:cs typeface="Courier New" pitchFamily="34" charset="-120"/>
-              </a:rPr>
-              <a:t>Next</a:t>
-            </a:r>
-            <a:endParaRPr lang="en-US" sz="2000" dirty="0"/>
-          </a:p>
-        </p:txBody>
-      </p:sp>
-      <p:sp>
-        <p:nvSpPr>
-          <p:cNvPr id="9" name="Text 7"/>
-          <p:cNvSpPr/>
-          <p:nvPr/>
-        </p:nvSpPr>
-        <p:spPr>
-          <a:xfrm>
-            <a:off x="6400800" y="2011680"/>
-            <a:ext cx="5029200" cy="3429000"/>
-          </a:xfrm>
-          <a:prstGeom prst="rect">
-            <a:avLst/>
-          </a:prstGeom>
-          <a:noFill/>
-          <a:ln/>
-        </p:spPr>
-        <p:txBody>
-          <a:bodyPr wrap="square" lIns="0" tIns="0" rIns="0" bIns="0" rtlCol="0" anchor="t"/>
-          <a:lstStyle/>
-          <a:p>
-            <a:pPr indent="0" marL="0">
-              <a:buNone/>
-            </a:pPr>
-            <a:r>
-              <a:rPr lang="en-US" sz="2000" dirty="0">
+              <a:t>Two machines linked over Tailscale (laptop and phone)</a:t>
+            </a:r>
+            <a:endParaRPr lang="en-US" sz="1600" dirty="0"/>
+          </a:p>
+          <a:p>
+            <a:pPr marL="342900" indent="-342900">
+              <a:spcAft>
+                <a:spcPts val="800"/>
+              </a:spcAft>
+              <a:buSzPct val="100000"/>
+              <a:buChar char="•"/>
+            </a:pPr>
+            <a:r>
+              <a:rPr lang="en-US" sz="1600" dirty="0">
                 <a:solidFill>
                   <a:srgbClr val="E6EDF3"/>
                 </a:solidFill>
@@ -6302,16 +6281,20 @@
                 <a:ea typeface="Calibri" pitchFamily="34" charset="-122"/>
                 <a:cs typeface="Calibri" pitchFamily="34" charset="-120"/>
               </a:rPr>
-              <a:t>Selective Repeat / SACK</a:t>
-            </a:r>
-            <a:endParaRPr lang="en-US" sz="2000" dirty="0"/>
-          </a:p>
-          <a:p>
-            <a:pPr indent="0" marL="0">
-              <a:buNone/>
-            </a:pPr>
-            <a:r>
-              <a:rPr lang="en-US" sz="2000" dirty="0">
+              <a:t>Loss slider: lost messages are resent and still arrive in order</a:t>
+            </a:r>
+            <a:endParaRPr lang="en-US" sz="1600" dirty="0"/>
+          </a:p>
+          <a:p>
+            <a:pPr marL="342900" indent="-342900">
+              <a:spcAft>
+                <a:spcPts val="800"/>
+              </a:spcAft>
+              <a:buSzPct val="100000"/>
+              <a:buChar char="•"/>
+            </a:pPr>
+            <a:r>
+              <a:rPr lang="en-US" sz="1600" dirty="0">
                 <a:solidFill>
                   <a:srgbClr val="E6EDF3"/>
                 </a:solidFill>
@@ -6319,82 +6302,9 @@
                 <a:ea typeface="Calibri" pitchFamily="34" charset="-122"/>
                 <a:cs typeface="Calibri" pitchFamily="34" charset="-120"/>
               </a:rPr>
-              <a:t>A stronger learning agent</a:t>
-            </a:r>
-            <a:endParaRPr lang="en-US" sz="2000" dirty="0"/>
-          </a:p>
-          <a:p>
-            <a:pPr indent="0" marL="0">
-              <a:buNone/>
-            </a:pPr>
-            <a:r>
-              <a:rPr lang="en-US" sz="2000" dirty="0">
-                <a:solidFill>
-                  <a:srgbClr val="E6EDF3"/>
-                </a:solidFill>
-                <a:latin typeface="Calibri" pitchFamily="34" charset="0"/>
-                <a:ea typeface="Calibri" pitchFamily="34" charset="-122"/>
-                <a:cs typeface="Calibri" pitchFamily="34" charset="-120"/>
-              </a:rPr>
-              <a:t>Kernel netem and real multi-machine tests</a:t>
-            </a:r>
-            <a:endParaRPr lang="en-US" sz="2000" dirty="0"/>
-          </a:p>
-          <a:p>
-            <a:pPr indent="0" marL="0">
-              <a:buNone/>
-            </a:pPr>
-            <a:r>
-              <a:rPr lang="en-US" sz="2000" dirty="0">
-                <a:solidFill>
-                  <a:srgbClr val="E6EDF3"/>
-                </a:solidFill>
-                <a:latin typeface="Calibri" pitchFamily="34" charset="0"/>
-                <a:ea typeface="Calibri" pitchFamily="34" charset="-122"/>
-                <a:cs typeface="Calibri" pitchFamily="34" charset="-120"/>
-              </a:rPr>
-              <a:t>Run RUDP across a real multi-machine network</a:t>
-            </a:r>
-            <a:endParaRPr lang="en-US" sz="2000" dirty="0"/>
-          </a:p>
-        </p:txBody>
-      </p:sp>
-      <p:sp>
-        <p:nvSpPr>
-          <p:cNvPr id="10" name="Text 8"/>
-          <p:cNvSpPr/>
-          <p:nvPr/>
-        </p:nvSpPr>
-        <p:spPr>
-          <a:xfrm>
-            <a:off x="548640" y="5852160"/>
-            <a:ext cx="10972800" cy="365760"/>
-          </a:xfrm>
-          <a:prstGeom prst="rect">
-            <a:avLst/>
-          </a:prstGeom>
-          <a:noFill/>
-          <a:ln/>
-        </p:spPr>
-        <p:txBody>
-          <a:bodyPr wrap="square" lIns="0" tIns="0" rIns="0" bIns="0" rtlCol="0" anchor="ctr"/>
-          <a:lstStyle/>
-          <a:p>
-            <a:pPr indent="0" marL="0">
-              <a:buNone/>
-            </a:pPr>
-            <a:r>
-              <a:rPr lang="en-US" sz="1400" dirty="0">
-                <a:solidFill>
-                  <a:srgbClr val="8B98A5"/>
-                </a:solidFill>
-                <a:latin typeface="Calibri" pitchFamily="34" charset="0"/>
-                <a:ea typeface="Calibri" pitchFamily="34" charset="-122"/>
-                <a:cs typeface="Calibri" pitchFamily="34" charset="-120"/>
-              </a:rPr>
-              <a:t>Limits: Go-Back-N wastes bandwidth; emulated (not kernel) paths; Smart-RUDP did not beat AIMD.</a:t>
-            </a:r>
-            <a:endParaRPr lang="en-US" sz="1400" dirty="0"/>
+              <a:t>Uses a fixed window of 8, not the Smart-RUDP controller</a:t>
+            </a:r>
+            <a:endParaRPr lang="en-US" sz="1600" dirty="0"/>
           </a:p>
         </p:txBody>
       </p:sp>
@@ -6502,7 +6412,7 @@
                 <a:ea typeface="Courier New" pitchFamily="34" charset="-122"/>
                 <a:cs typeface="Courier New" pitchFamily="34" charset="-120"/>
               </a:rPr>
-              <a:t>2 / 20   Smart-RUDP</a:t>
+              <a:t>2 / 21   Smart-RUDP</a:t>
             </a:r>
             <a:endParaRPr lang="en-US" sz="1000" dirty="0"/>
           </a:p>
@@ -6832,8 +6742,8 @@
         </p:nvSpPr>
         <p:spPr>
           <a:xfrm>
-            <a:off x="731520" y="2103120"/>
-            <a:ext cx="10058400" cy="1097280"/>
+            <a:off x="548640" y="320040"/>
+            <a:ext cx="11064240" cy="731520"/>
           </a:xfrm>
           <a:prstGeom prst="rect">
             <a:avLst/>
@@ -6849,7 +6759,7 @@
               <a:buNone/>
             </a:pPr>
             <a:r>
-              <a:rPr lang="en-US" sz="6400" b="1" dirty="0">
+              <a:rPr lang="en-US" sz="3000" b="1" dirty="0">
                 <a:solidFill>
                   <a:srgbClr val="39FF88"/>
                 </a:solidFill>
@@ -6857,9 +6767,9 @@
                 <a:ea typeface="Courier New" pitchFamily="34" charset="-122"/>
                 <a:cs typeface="Courier New" pitchFamily="34" charset="-120"/>
               </a:rPr>
-              <a:t>Thank you</a:t>
-            </a:r>
-            <a:endParaRPr lang="en-US" sz="6400" dirty="0"/>
+              <a:t>Learnings and future work</a:t>
+            </a:r>
+            <a:endParaRPr lang="en-US" sz="3000" dirty="0"/>
           </a:p>
         </p:txBody>
       </p:sp>
@@ -6871,8 +6781,8 @@
         </p:nvSpPr>
         <p:spPr>
           <a:xfrm>
-            <a:off x="731520" y="3474720"/>
-            <a:ext cx="10058400" cy="548640"/>
+            <a:off x="9418320" y="6446520"/>
+            <a:ext cx="2377440" cy="274320"/>
           </a:xfrm>
           <a:prstGeom prst="rect">
             <a:avLst/>
@@ -6884,34 +6794,59 @@
           <a:bodyPr wrap="square" lIns="0" tIns="0" rIns="0" bIns="0" rtlCol="0" anchor="ctr"/>
           <a:lstStyle/>
           <a:p>
-            <a:pPr indent="0" marL="0">
-              <a:buNone/>
-            </a:pPr>
-            <a:r>
-              <a:rPr lang="en-US" sz="2600" dirty="0">
-                <a:solidFill>
-                  <a:srgbClr val="E6EDF3"/>
+            <a:pPr algn="r" indent="0" marL="0">
+              <a:buNone/>
+            </a:pPr>
+            <a:r>
+              <a:rPr lang="en-US" sz="1000" dirty="0">
+                <a:solidFill>
+                  <a:srgbClr val="8B98A5"/>
                 </a:solidFill>
                 <a:latin typeface="Courier New" pitchFamily="34" charset="0"/>
                 <a:ea typeface="Courier New" pitchFamily="34" charset="-122"/>
                 <a:cs typeface="Courier New" pitchFamily="34" charset="-120"/>
               </a:rPr>
-              <a:t>github.com/Capsturrrr/rudp</a:t>
-            </a:r>
-            <a:endParaRPr lang="en-US" sz="2600" dirty="0"/>
-          </a:p>
-        </p:txBody>
-      </p:sp>
-      <p:sp>
-        <p:nvSpPr>
-          <p:cNvPr id="4" name="Text 2"/>
-          <p:cNvSpPr/>
-          <p:nvPr/>
-        </p:nvSpPr>
-        <p:spPr>
-          <a:xfrm>
-            <a:off x="731520" y="4206240"/>
-            <a:ext cx="10058400" cy="457200"/>
+              <a:t>20 / 21   Smart-RUDP</a:t>
+            </a:r>
+            <a:endParaRPr lang="en-US" sz="1000" dirty="0"/>
+          </a:p>
+        </p:txBody>
+      </p:sp>
+      <p:sp>
+        <p:nvSpPr>
+          <p:cNvPr id="4" name="Shape 2"/>
+          <p:cNvSpPr/>
+          <p:nvPr/>
+        </p:nvSpPr>
+        <p:spPr>
+          <a:xfrm>
+            <a:off x="548640" y="1371600"/>
+            <a:ext cx="5394960" cy="4206240"/>
+          </a:xfrm>
+          <a:prstGeom prst="rect">
+            <a:avLst/>
+          </a:prstGeom>
+          <a:solidFill>
+            <a:srgbClr val="141B24"/>
+          </a:solidFill>
+          <a:ln w="12700">
+            <a:solidFill>
+              <a:srgbClr val="39FF88"/>
+            </a:solidFill>
+            <a:prstDash val="solid"/>
+          </a:ln>
+        </p:spPr>
+      </p:sp>
+      <p:sp>
+        <p:nvSpPr>
+          <p:cNvPr id="5" name="Text 3"/>
+          <p:cNvSpPr/>
+          <p:nvPr/>
+        </p:nvSpPr>
+        <p:spPr>
+          <a:xfrm>
+            <a:off x="731520" y="1508760"/>
+            <a:ext cx="5029200" cy="457200"/>
           </a:xfrm>
           <a:prstGeom prst="rect">
             <a:avLst/>
@@ -6927,17 +6862,283 @@
               <a:buNone/>
             </a:pPr>
             <a:r>
-              <a:rPr lang="en-US" sz="1800" dirty="0">
-                <a:solidFill>
-                  <a:srgbClr val="8B98A5"/>
+              <a:rPr lang="en-US" sz="2000" b="1" dirty="0">
+                <a:solidFill>
+                  <a:srgbClr val="39FF88"/>
+                </a:solidFill>
+                <a:latin typeface="Courier New" pitchFamily="34" charset="0"/>
+                <a:ea typeface="Courier New" pitchFamily="34" charset="-122"/>
+                <a:cs typeface="Courier New" pitchFamily="34" charset="-120"/>
+              </a:rPr>
+              <a:t>Learned</a:t>
+            </a:r>
+            <a:endParaRPr lang="en-US" sz="2000" dirty="0"/>
+          </a:p>
+        </p:txBody>
+      </p:sp>
+      <p:sp>
+        <p:nvSpPr>
+          <p:cNvPr id="6" name="Text 4"/>
+          <p:cNvSpPr/>
+          <p:nvPr/>
+        </p:nvSpPr>
+        <p:spPr>
+          <a:xfrm>
+            <a:off x="731520" y="2011680"/>
+            <a:ext cx="5029200" cy="3429000"/>
+          </a:xfrm>
+          <a:prstGeom prst="rect">
+            <a:avLst/>
+          </a:prstGeom>
+          <a:noFill/>
+          <a:ln/>
+        </p:spPr>
+        <p:txBody>
+          <a:bodyPr wrap="square" lIns="0" tIns="0" rIns="0" bIns="0" rtlCol="0" anchor="t"/>
+          <a:lstStyle/>
+          <a:p>
+            <a:pPr indent="0" marL="0">
+              <a:buNone/>
+            </a:pPr>
+            <a:r>
+              <a:rPr lang="en-US" sz="2000" dirty="0">
+                <a:solidFill>
+                  <a:srgbClr val="E6EDF3"/>
                 </a:solidFill>
                 <a:latin typeface="Calibri" pitchFamily="34" charset="0"/>
                 <a:ea typeface="Calibri" pitchFamily="34" charset="-122"/>
                 <a:cs typeface="Calibri" pitchFamily="34" charset="-120"/>
               </a:rPr>
-              <a:t>Harshavardhan Mallela   Rohit Arya   Shloak Sinha</a:t>
-            </a:r>
-            <a:endParaRPr lang="en-US" sz="1800" dirty="0"/>
+              <a:t>Reliability is a set of simple rules working together.</a:t>
+            </a:r>
+            <a:endParaRPr lang="en-US" sz="2000" dirty="0"/>
+          </a:p>
+          <a:p>
+            <a:pPr indent="0" marL="0">
+              <a:buNone/>
+            </a:pPr>
+            <a:r>
+              <a:rPr lang="en-US" sz="2000" dirty="0">
+                <a:solidFill>
+                  <a:srgbClr val="E6EDF3"/>
+                </a:solidFill>
+                <a:latin typeface="Calibri" pitchFamily="34" charset="0"/>
+                <a:ea typeface="Calibri" pitchFamily="34" charset="-122"/>
+                <a:cs typeface="Calibri" pitchFamily="34" charset="-120"/>
+              </a:rPr>
+              <a:t>Congestion control matters as much as retransmission.</a:t>
+            </a:r>
+            <a:endParaRPr lang="en-US" sz="2000" dirty="0"/>
+          </a:p>
+          <a:p>
+            <a:pPr indent="0" marL="0">
+              <a:buNone/>
+            </a:pPr>
+            <a:r>
+              <a:rPr lang="en-US" sz="2000" dirty="0">
+                <a:solidFill>
+                  <a:srgbClr val="E6EDF3"/>
+                </a:solidFill>
+                <a:latin typeface="Calibri" pitchFamily="34" charset="0"/>
+                <a:ea typeface="Calibri" pitchFamily="34" charset="-122"/>
+                <a:cs typeface="Calibri" pitchFamily="34" charset="-120"/>
+              </a:rPr>
+              <a:t>Testing tools fail in surprising ways.</a:t>
+            </a:r>
+            <a:endParaRPr lang="en-US" sz="2000" dirty="0"/>
+          </a:p>
+        </p:txBody>
+      </p:sp>
+      <p:sp>
+        <p:nvSpPr>
+          <p:cNvPr id="7" name="Shape 5"/>
+          <p:cNvSpPr/>
+          <p:nvPr/>
+        </p:nvSpPr>
+        <p:spPr>
+          <a:xfrm>
+            <a:off x="6217920" y="1371600"/>
+            <a:ext cx="5394960" cy="4206240"/>
+          </a:xfrm>
+          <a:prstGeom prst="rect">
+            <a:avLst/>
+          </a:prstGeom>
+          <a:solidFill>
+            <a:srgbClr val="141B24"/>
+          </a:solidFill>
+          <a:ln w="12700">
+            <a:solidFill>
+              <a:srgbClr val="FFB000"/>
+            </a:solidFill>
+            <a:prstDash val="solid"/>
+          </a:ln>
+        </p:spPr>
+      </p:sp>
+      <p:sp>
+        <p:nvSpPr>
+          <p:cNvPr id="8" name="Text 6"/>
+          <p:cNvSpPr/>
+          <p:nvPr/>
+        </p:nvSpPr>
+        <p:spPr>
+          <a:xfrm>
+            <a:off x="6400800" y="1508760"/>
+            <a:ext cx="5029200" cy="457200"/>
+          </a:xfrm>
+          <a:prstGeom prst="rect">
+            <a:avLst/>
+          </a:prstGeom>
+          <a:noFill/>
+          <a:ln/>
+        </p:spPr>
+        <p:txBody>
+          <a:bodyPr wrap="square" lIns="0" tIns="0" rIns="0" bIns="0" rtlCol="0" anchor="ctr"/>
+          <a:lstStyle/>
+          <a:p>
+            <a:pPr indent="0" marL="0">
+              <a:buNone/>
+            </a:pPr>
+            <a:r>
+              <a:rPr lang="en-US" sz="2000" b="1" dirty="0">
+                <a:solidFill>
+                  <a:srgbClr val="FFB000"/>
+                </a:solidFill>
+                <a:latin typeface="Courier New" pitchFamily="34" charset="0"/>
+                <a:ea typeface="Courier New" pitchFamily="34" charset="-122"/>
+                <a:cs typeface="Courier New" pitchFamily="34" charset="-120"/>
+              </a:rPr>
+              <a:t>Next</a:t>
+            </a:r>
+            <a:endParaRPr lang="en-US" sz="2000" dirty="0"/>
+          </a:p>
+        </p:txBody>
+      </p:sp>
+      <p:sp>
+        <p:nvSpPr>
+          <p:cNvPr id="9" name="Text 7"/>
+          <p:cNvSpPr/>
+          <p:nvPr/>
+        </p:nvSpPr>
+        <p:spPr>
+          <a:xfrm>
+            <a:off x="6400800" y="2011680"/>
+            <a:ext cx="5029200" cy="3429000"/>
+          </a:xfrm>
+          <a:prstGeom prst="rect">
+            <a:avLst/>
+          </a:prstGeom>
+          <a:noFill/>
+          <a:ln/>
+        </p:spPr>
+        <p:txBody>
+          <a:bodyPr wrap="square" lIns="0" tIns="0" rIns="0" bIns="0" rtlCol="0" anchor="t"/>
+          <a:lstStyle/>
+          <a:p>
+            <a:pPr indent="0" marL="0">
+              <a:buNone/>
+            </a:pPr>
+            <a:r>
+              <a:rPr lang="en-US" sz="2000" dirty="0">
+                <a:solidFill>
+                  <a:srgbClr val="E6EDF3"/>
+                </a:solidFill>
+                <a:latin typeface="Calibri" pitchFamily="34" charset="0"/>
+                <a:ea typeface="Calibri" pitchFamily="34" charset="-122"/>
+                <a:cs typeface="Calibri" pitchFamily="34" charset="-120"/>
+              </a:rPr>
+              <a:t>Selective Repeat / SACK</a:t>
+            </a:r>
+            <a:endParaRPr lang="en-US" sz="2000" dirty="0"/>
+          </a:p>
+          <a:p>
+            <a:pPr indent="0" marL="0">
+              <a:buNone/>
+            </a:pPr>
+            <a:r>
+              <a:rPr lang="en-US" sz="2000" dirty="0">
+                <a:solidFill>
+                  <a:srgbClr val="E6EDF3"/>
+                </a:solidFill>
+                <a:latin typeface="Calibri" pitchFamily="34" charset="0"/>
+                <a:ea typeface="Calibri" pitchFamily="34" charset="-122"/>
+                <a:cs typeface="Calibri" pitchFamily="34" charset="-120"/>
+              </a:rPr>
+              <a:t>A stronger learning agent</a:t>
+            </a:r>
+            <a:endParaRPr lang="en-US" sz="2000" dirty="0"/>
+          </a:p>
+          <a:p>
+            <a:pPr indent="0" marL="0">
+              <a:buNone/>
+            </a:pPr>
+            <a:r>
+              <a:rPr lang="en-US" sz="2000" dirty="0">
+                <a:solidFill>
+                  <a:srgbClr val="E6EDF3"/>
+                </a:solidFill>
+                <a:latin typeface="Calibri" pitchFamily="34" charset="0"/>
+                <a:ea typeface="Calibri" pitchFamily="34" charset="-122"/>
+                <a:cs typeface="Calibri" pitchFamily="34" charset="-120"/>
+              </a:rPr>
+              <a:t>Kernel netem and real multi-machine tests</a:t>
+            </a:r>
+            <a:endParaRPr lang="en-US" sz="2000" dirty="0"/>
+          </a:p>
+          <a:p>
+            <a:pPr indent="0" marL="0">
+              <a:buNone/>
+            </a:pPr>
+            <a:r>
+              <a:rPr lang="en-US" sz="2000" dirty="0">
+                <a:solidFill>
+                  <a:srgbClr val="E6EDF3"/>
+                </a:solidFill>
+                <a:latin typeface="Calibri" pitchFamily="34" charset="0"/>
+                <a:ea typeface="Calibri" pitchFamily="34" charset="-122"/>
+                <a:cs typeface="Calibri" pitchFamily="34" charset="-120"/>
+              </a:rPr>
+              <a:t>Run RUDP across a real multi-machine network</a:t>
+            </a:r>
+            <a:endParaRPr lang="en-US" sz="2000" dirty="0"/>
+          </a:p>
+        </p:txBody>
+      </p:sp>
+      <p:sp>
+        <p:nvSpPr>
+          <p:cNvPr id="10" name="Text 8"/>
+          <p:cNvSpPr/>
+          <p:nvPr/>
+        </p:nvSpPr>
+        <p:spPr>
+          <a:xfrm>
+            <a:off x="548640" y="5852160"/>
+            <a:ext cx="10972800" cy="365760"/>
+          </a:xfrm>
+          <a:prstGeom prst="rect">
+            <a:avLst/>
+          </a:prstGeom>
+          <a:noFill/>
+          <a:ln/>
+        </p:spPr>
+        <p:txBody>
+          <a:bodyPr wrap="square" lIns="0" tIns="0" rIns="0" bIns="0" rtlCol="0" anchor="ctr"/>
+          <a:lstStyle/>
+          <a:p>
+            <a:pPr indent="0" marL="0">
+              <a:buNone/>
+            </a:pPr>
+            <a:r>
+              <a:rPr lang="en-US" sz="1400" dirty="0">
+                <a:solidFill>
+                  <a:srgbClr val="8B98A5"/>
+                </a:solidFill>
+                <a:latin typeface="Calibri" pitchFamily="34" charset="0"/>
+                <a:ea typeface="Calibri" pitchFamily="34" charset="-122"/>
+                <a:cs typeface="Calibri" pitchFamily="34" charset="-120"/>
+              </a:rPr>
+              <a:t>Limits: Go-Back-N wastes bandwidth; emulated (not kernel) paths; Smart-RUDP did not beat AIMD.</a:t>
+            </a:r>
+            <a:endParaRPr lang="en-US" sz="1400" dirty="0"/>
           </a:p>
         </p:txBody>
       </p:sp>
@@ -6981,6 +7182,155 @@
         </p:nvSpPr>
         <p:spPr>
           <a:xfrm>
+            <a:off x="731520" y="2103120"/>
+            <a:ext cx="10058400" cy="1097280"/>
+          </a:xfrm>
+          <a:prstGeom prst="rect">
+            <a:avLst/>
+          </a:prstGeom>
+          <a:noFill/>
+          <a:ln/>
+        </p:spPr>
+        <p:txBody>
+          <a:bodyPr wrap="square" lIns="0" tIns="0" rIns="0" bIns="0" rtlCol="0" anchor="ctr"/>
+          <a:lstStyle/>
+          <a:p>
+            <a:pPr indent="0" marL="0">
+              <a:buNone/>
+            </a:pPr>
+            <a:r>
+              <a:rPr lang="en-US" sz="6400" b="1" dirty="0">
+                <a:solidFill>
+                  <a:srgbClr val="39FF88"/>
+                </a:solidFill>
+                <a:latin typeface="Courier New" pitchFamily="34" charset="0"/>
+                <a:ea typeface="Courier New" pitchFamily="34" charset="-122"/>
+                <a:cs typeface="Courier New" pitchFamily="34" charset="-120"/>
+              </a:rPr>
+              <a:t>Thank you</a:t>
+            </a:r>
+            <a:endParaRPr lang="en-US" sz="6400" dirty="0"/>
+          </a:p>
+        </p:txBody>
+      </p:sp>
+      <p:sp>
+        <p:nvSpPr>
+          <p:cNvPr id="3" name="Text 1"/>
+          <p:cNvSpPr/>
+          <p:nvPr/>
+        </p:nvSpPr>
+        <p:spPr>
+          <a:xfrm>
+            <a:off x="731520" y="3474720"/>
+            <a:ext cx="10058400" cy="548640"/>
+          </a:xfrm>
+          <a:prstGeom prst="rect">
+            <a:avLst/>
+          </a:prstGeom>
+          <a:noFill/>
+          <a:ln/>
+        </p:spPr>
+        <p:txBody>
+          <a:bodyPr wrap="square" lIns="0" tIns="0" rIns="0" bIns="0" rtlCol="0" anchor="ctr"/>
+          <a:lstStyle/>
+          <a:p>
+            <a:pPr indent="0" marL="0">
+              <a:buNone/>
+            </a:pPr>
+            <a:r>
+              <a:rPr lang="en-US" sz="2600" dirty="0">
+                <a:solidFill>
+                  <a:srgbClr val="E6EDF3"/>
+                </a:solidFill>
+                <a:latin typeface="Courier New" pitchFamily="34" charset="0"/>
+                <a:ea typeface="Courier New" pitchFamily="34" charset="-122"/>
+                <a:cs typeface="Courier New" pitchFamily="34" charset="-120"/>
+              </a:rPr>
+              <a:t>github.com/Capsturrrr/rudp</a:t>
+            </a:r>
+            <a:endParaRPr lang="en-US" sz="2600" dirty="0"/>
+          </a:p>
+        </p:txBody>
+      </p:sp>
+      <p:sp>
+        <p:nvSpPr>
+          <p:cNvPr id="4" name="Text 2"/>
+          <p:cNvSpPr/>
+          <p:nvPr/>
+        </p:nvSpPr>
+        <p:spPr>
+          <a:xfrm>
+            <a:off x="731520" y="4206240"/>
+            <a:ext cx="10058400" cy="457200"/>
+          </a:xfrm>
+          <a:prstGeom prst="rect">
+            <a:avLst/>
+          </a:prstGeom>
+          <a:noFill/>
+          <a:ln/>
+        </p:spPr>
+        <p:txBody>
+          <a:bodyPr wrap="square" lIns="0" tIns="0" rIns="0" bIns="0" rtlCol="0" anchor="ctr"/>
+          <a:lstStyle/>
+          <a:p>
+            <a:pPr indent="0" marL="0">
+              <a:buNone/>
+            </a:pPr>
+            <a:r>
+              <a:rPr lang="en-US" sz="1800" dirty="0">
+                <a:solidFill>
+                  <a:srgbClr val="8B98A5"/>
+                </a:solidFill>
+                <a:latin typeface="Calibri" pitchFamily="34" charset="0"/>
+                <a:ea typeface="Calibri" pitchFamily="34" charset="-122"/>
+                <a:cs typeface="Calibri" pitchFamily="34" charset="-120"/>
+              </a:rPr>
+              <a:t>Harshavardhan Mallela   Rohit Arya   Shloak Sinha</a:t>
+            </a:r>
+            <a:endParaRPr lang="en-US" sz="1800" dirty="0"/>
+          </a:p>
+        </p:txBody>
+      </p:sp>
+    </p:spTree>
+  </p:cSld>
+  <p:clrMapOvr>
+    <a:masterClrMapping/>
+  </p:clrMapOvr>
+</p:sld>
+</file>
+
+<file path=ppt/slides/slide22.xml><?xml version="1.0" encoding="utf-8"?>
+<p:sld xmlns:a="http://schemas.openxmlformats.org/drawingml/2006/main" xmlns:r="http://schemas.openxmlformats.org/officeDocument/2006/relationships" xmlns:p="http://schemas.openxmlformats.org/presentationml/2006/main">
+  <p:cSld name="Slide 22">
+    <p:bg>
+      <p:bgPr>
+        <a:solidFill>
+          <a:srgbClr val="0B0F14"/>
+        </a:solidFill>
+      </p:bgPr>
+    </p:bg>
+    <p:spTree>
+      <p:nvGrpSpPr>
+        <p:cNvPr id="1" name=""/>
+        <p:cNvGrpSpPr/>
+        <p:nvPr/>
+      </p:nvGrpSpPr>
+      <p:grpSpPr>
+        <a:xfrm>
+          <a:off x="0" y="0"/>
+          <a:ext cx="0" cy="0"/>
+          <a:chOff x="0" y="0"/>
+          <a:chExt cx="0" cy="0"/>
+        </a:xfrm>
+      </p:grpSpPr>
+      <p:sp>
+        <p:nvSpPr>
+          <p:cNvPr id="2" name="Text 0"/>
+          <p:cNvSpPr/>
+          <p:nvPr/>
+        </p:nvSpPr>
+        <p:spPr>
+          <a:xfrm>
             <a:off x="548640" y="320040"/>
             <a:ext cx="11064240" cy="731520"/>
           </a:xfrm>
@@ -7285,7 +7635,7 @@
                 <a:ea typeface="Courier New" pitchFamily="34" charset="-122"/>
                 <a:cs typeface="Courier New" pitchFamily="34" charset="-120"/>
               </a:rPr>
-              <a:t>3 / 20   Smart-RUDP</a:t>
+              <a:t>3 / 21   Smart-RUDP</a:t>
             </a:r>
             <a:endParaRPr lang="en-US" sz="1000" dirty="0"/>
           </a:p>
@@ -7679,7 +8029,7 @@
                 <a:ea typeface="Courier New" pitchFamily="34" charset="-122"/>
                 <a:cs typeface="Courier New" pitchFamily="34" charset="-120"/>
               </a:rPr>
-              <a:t>4 / 20   Smart-RUDP</a:t>
+              <a:t>4 / 21   Smart-RUDP</a:t>
             </a:r>
             <a:endParaRPr lang="en-US" sz="1000" dirty="0"/>
           </a:p>
@@ -8240,7 +8590,7 @@
                 <a:ea typeface="Courier New" pitchFamily="34" charset="-122"/>
                 <a:cs typeface="Courier New" pitchFamily="34" charset="-120"/>
               </a:rPr>
-              <a:t>5 / 20   Smart-RUDP</a:t>
+              <a:t>5 / 21   Smart-RUDP</a:t>
             </a:r>
             <a:endParaRPr lang="en-US" sz="1000" dirty="0"/>
           </a:p>
@@ -9679,7 +10029,7 @@
                 <a:ea typeface="Courier New" pitchFamily="34" charset="-122"/>
                 <a:cs typeface="Courier New" pitchFamily="34" charset="-120"/>
               </a:rPr>
-              <a:t>6 / 20   Smart-RUDP</a:t>
+              <a:t>6 / 21   Smart-RUDP</a:t>
             </a:r>
             <a:endParaRPr lang="en-US" sz="1000" dirty="0"/>
           </a:p>
@@ -10914,7 +11264,7 @@
                 <a:ea typeface="Courier New" pitchFamily="34" charset="-122"/>
                 <a:cs typeface="Courier New" pitchFamily="34" charset="-120"/>
               </a:rPr>
-              <a:t>7 / 20   Smart-RUDP</a:t>
+              <a:t>7 / 21   Smart-RUDP</a:t>
             </a:r>
             <a:endParaRPr lang="en-US" sz="1000" dirty="0"/>
           </a:p>
@@ -11357,7 +11707,7 @@
                 <a:ea typeface="Courier New" pitchFamily="34" charset="-122"/>
                 <a:cs typeface="Courier New" pitchFamily="34" charset="-120"/>
               </a:rPr>
-              <a:t>8 / 20   Smart-RUDP</a:t>
+              <a:t>8 / 21   Smart-RUDP</a:t>
             </a:r>
             <a:endParaRPr lang="en-US" sz="1000" dirty="0"/>
           </a:p>
@@ -11657,7 +12007,7 @@
                 <a:ea typeface="Courier New" pitchFamily="34" charset="-122"/>
                 <a:cs typeface="Courier New" pitchFamily="34" charset="-120"/>
               </a:rPr>
-              <a:t>9 / 20   Smart-RUDP</a:t>
+              <a:t>9 / 21   Smart-RUDP</a:t>
             </a:r>
             <a:endParaRPr lang="en-US" sz="1000" dirty="0"/>
           </a:p>

</xml_diff>